<commit_message>
Significant changes to the whole flow of slides creation (individually) and the final deck.
</commit_message>
<xml_diff>
--- a/templates/Brochure_template_leaflet_4sides/Brochure_template_leaflet_4sides.pptx
+++ b/templates/Brochure_template_leaflet_4sides/Brochure_template_leaflet_4sides.pptx
@@ -118,7 +118,7 @@
 <file path=ppt/revisionInfo.xml><?xml version="1.0" encoding="utf-8"?>
 <p1510:revInfo xmlns:a="http://schemas.openxmlformats.org/drawingml/2006/main" xmlns:r="http://schemas.openxmlformats.org/officeDocument/2006/relationships" xmlns:p1510="http://schemas.microsoft.com/office/powerpoint/2015/10/main">
   <p1510:revLst>
-    <p1510:client id="{85B83225-0F8B-4540-96C4-3916D224CEC7}" v="264" dt="2025-08-13T22:18:27.754"/>
+    <p1510:client id="{87A27B4C-FB13-9545-B06C-83D288B68DDE}" v="123" dt="2025-08-15T08:25:24.022"/>
   </p1510:revLst>
 </p1510:revInfo>
 </file>
@@ -126,43 +126,724 @@
 <file path=ppt/changesInfos/changesInfo1.xml><?xml version="1.0" encoding="utf-8"?>
 <pc:chgInfo xmlns:a="http://schemas.openxmlformats.org/drawingml/2006/main" xmlns:r="http://schemas.openxmlformats.org/officeDocument/2006/relationships" xmlns:ac="http://schemas.microsoft.com/office/drawing/2013/main/command" xmlns:pc="http://schemas.microsoft.com/office/powerpoint/2013/main/command">
   <pc:docChgLst>
-    <pc:chgData name="Sam Khalil" userId="82cd1ec2-6208-465b-9d4d-40ce8f0cbf96" providerId="ADAL" clId="{85B83225-0F8B-4540-96C4-3916D224CEC7}"/>
-    <pc:docChg chg="undo custSel addSld delSld modMainMaster">
-      <pc:chgData name="Sam Khalil" userId="82cd1ec2-6208-465b-9d4d-40ce8f0cbf96" providerId="ADAL" clId="{85B83225-0F8B-4540-96C4-3916D224CEC7}" dt="2025-08-13T22:18:27.754" v="968"/>
+    <pc:chgData name="Sam Khalil" userId="82cd1ec2-6208-465b-9d4d-40ce8f0cbf96" providerId="ADAL" clId="{87A27B4C-FB13-9545-B06C-83D288B68DDE}"/>
+    <pc:docChg chg="undo custSel addSld delSld modSld addMainMaster delMainMaster modMainMaster">
+      <pc:chgData name="Sam Khalil" userId="82cd1ec2-6208-465b-9d4d-40ce8f0cbf96" providerId="ADAL" clId="{87A27B4C-FB13-9545-B06C-83D288B68DDE}" dt="2025-08-15T08:47:03.379" v="290" actId="2696"/>
       <pc:docMkLst>
         <pc:docMk/>
       </pc:docMkLst>
-      <pc:sldChg chg="new del">
-        <pc:chgData name="Sam Khalil" userId="82cd1ec2-6208-465b-9d4d-40ce8f0cbf96" providerId="ADAL" clId="{85B83225-0F8B-4540-96C4-3916D224CEC7}" dt="2025-08-13T21:15:54.345" v="952" actId="2696"/>
+      <pc:sldChg chg="modSp new add del mod">
+        <pc:chgData name="Sam Khalil" userId="82cd1ec2-6208-465b-9d4d-40ce8f0cbf96" providerId="ADAL" clId="{87A27B4C-FB13-9545-B06C-83D288B68DDE}" dt="2025-08-15T08:26:05.466" v="287" actId="2696"/>
         <pc:sldMkLst>
           <pc:docMk/>
-          <pc:sldMk cId="1890799231" sldId="256"/>
+          <pc:sldMk cId="382125220" sldId="256"/>
+        </pc:sldMkLst>
+        <pc:spChg chg="mod">
+          <ac:chgData name="Sam Khalil" userId="82cd1ec2-6208-465b-9d4d-40ce8f0cbf96" providerId="ADAL" clId="{87A27B4C-FB13-9545-B06C-83D288B68DDE}" dt="2025-08-15T07:05:37.813" v="251" actId="20577"/>
+          <ac:spMkLst>
+            <pc:docMk/>
+            <pc:sldMk cId="382125220" sldId="256"/>
+            <ac:spMk id="4" creationId="{4D442D54-E960-5707-560F-E146C291BAE8}"/>
+          </ac:spMkLst>
+        </pc:spChg>
+        <pc:spChg chg="mod">
+          <ac:chgData name="Sam Khalil" userId="82cd1ec2-6208-465b-9d4d-40ce8f0cbf96" providerId="ADAL" clId="{87A27B4C-FB13-9545-B06C-83D288B68DDE}" dt="2025-08-15T07:03:29.684" v="218" actId="20577"/>
+          <ac:spMkLst>
+            <pc:docMk/>
+            <pc:sldMk cId="382125220" sldId="256"/>
+            <ac:spMk id="11" creationId="{2F1ABFBE-43F8-FF98-87C4-4F29A7477711}"/>
+          </ac:spMkLst>
+        </pc:spChg>
+      </pc:sldChg>
+      <pc:sldChg chg="addSp delSp modSp new del mod chgLayout">
+        <pc:chgData name="Sam Khalil" userId="82cd1ec2-6208-465b-9d4d-40ce8f0cbf96" providerId="ADAL" clId="{87A27B4C-FB13-9545-B06C-83D288B68DDE}" dt="2025-08-15T06:50:35.706" v="169" actId="2696"/>
+        <pc:sldMkLst>
+          <pc:docMk/>
+          <pc:sldMk cId="1648052740" sldId="256"/>
+        </pc:sldMkLst>
+        <pc:spChg chg="del">
+          <ac:chgData name="Sam Khalil" userId="82cd1ec2-6208-465b-9d4d-40ce8f0cbf96" providerId="ADAL" clId="{87A27B4C-FB13-9545-B06C-83D288B68DDE}" dt="2025-08-15T06:49:26.247" v="161" actId="6264"/>
+          <ac:spMkLst>
+            <pc:docMk/>
+            <pc:sldMk cId="1648052740" sldId="256"/>
+            <ac:spMk id="4" creationId="{E984FD35-6E0C-359B-FF77-1F5041B7446E}"/>
+          </ac:spMkLst>
+        </pc:spChg>
+        <pc:spChg chg="del">
+          <ac:chgData name="Sam Khalil" userId="82cd1ec2-6208-465b-9d4d-40ce8f0cbf96" providerId="ADAL" clId="{87A27B4C-FB13-9545-B06C-83D288B68DDE}" dt="2025-08-15T06:49:26.247" v="161" actId="6264"/>
+          <ac:spMkLst>
+            <pc:docMk/>
+            <pc:sldMk cId="1648052740" sldId="256"/>
+            <ac:spMk id="5" creationId="{B636840A-D3FF-CDA2-E31E-5503524DC120}"/>
+          </ac:spMkLst>
+        </pc:spChg>
+        <pc:spChg chg="del">
+          <ac:chgData name="Sam Khalil" userId="82cd1ec2-6208-465b-9d4d-40ce8f0cbf96" providerId="ADAL" clId="{87A27B4C-FB13-9545-B06C-83D288B68DDE}" dt="2025-08-15T06:49:26.247" v="161" actId="6264"/>
+          <ac:spMkLst>
+            <pc:docMk/>
+            <pc:sldMk cId="1648052740" sldId="256"/>
+            <ac:spMk id="6" creationId="{6F0EECFB-2738-A961-B05F-18073F4DD590}"/>
+          </ac:spMkLst>
+        </pc:spChg>
+        <pc:spChg chg="del">
+          <ac:chgData name="Sam Khalil" userId="82cd1ec2-6208-465b-9d4d-40ce8f0cbf96" providerId="ADAL" clId="{87A27B4C-FB13-9545-B06C-83D288B68DDE}" dt="2025-08-15T06:49:26.247" v="161" actId="6264"/>
+          <ac:spMkLst>
+            <pc:docMk/>
+            <pc:sldMk cId="1648052740" sldId="256"/>
+            <ac:spMk id="7" creationId="{9C3D70A5-C8CB-F6C3-2658-C02C548BEC73}"/>
+          </ac:spMkLst>
+        </pc:spChg>
+        <pc:spChg chg="del">
+          <ac:chgData name="Sam Khalil" userId="82cd1ec2-6208-465b-9d4d-40ce8f0cbf96" providerId="ADAL" clId="{87A27B4C-FB13-9545-B06C-83D288B68DDE}" dt="2025-08-15T06:49:26.247" v="161" actId="6264"/>
+          <ac:spMkLst>
+            <pc:docMk/>
+            <pc:sldMk cId="1648052740" sldId="256"/>
+            <ac:spMk id="10" creationId="{307B0994-5F01-BCD5-A93A-7BF08D62E2CE}"/>
+          </ac:spMkLst>
+        </pc:spChg>
+        <pc:spChg chg="del">
+          <ac:chgData name="Sam Khalil" userId="82cd1ec2-6208-465b-9d4d-40ce8f0cbf96" providerId="ADAL" clId="{87A27B4C-FB13-9545-B06C-83D288B68DDE}" dt="2025-08-15T06:50:27.733" v="168" actId="6264"/>
+          <ac:spMkLst>
+            <pc:docMk/>
+            <pc:sldMk cId="1648052740" sldId="256"/>
+            <ac:spMk id="12" creationId="{69B46F38-A99B-9595-BA96-E2368725875B}"/>
+          </ac:spMkLst>
+        </pc:spChg>
+        <pc:spChg chg="del">
+          <ac:chgData name="Sam Khalil" userId="82cd1ec2-6208-465b-9d4d-40ce8f0cbf96" providerId="ADAL" clId="{87A27B4C-FB13-9545-B06C-83D288B68DDE}" dt="2025-08-15T06:50:27.733" v="168" actId="6264"/>
+          <ac:spMkLst>
+            <pc:docMk/>
+            <pc:sldMk cId="1648052740" sldId="256"/>
+            <ac:spMk id="13" creationId="{81B32AF6-BC0F-0EE8-0E67-F698688ABE83}"/>
+          </ac:spMkLst>
+        </pc:spChg>
+        <pc:spChg chg="add mod ord">
+          <ac:chgData name="Sam Khalil" userId="82cd1ec2-6208-465b-9d4d-40ce8f0cbf96" providerId="ADAL" clId="{87A27B4C-FB13-9545-B06C-83D288B68DDE}" dt="2025-08-15T06:49:26.247" v="161" actId="6264"/>
+          <ac:spMkLst>
+            <pc:docMk/>
+            <pc:sldMk cId="1648052740" sldId="256"/>
+            <ac:spMk id="14" creationId="{4E62547A-3350-4994-C586-50D7D35A404E}"/>
+          </ac:spMkLst>
+        </pc:spChg>
+        <pc:spChg chg="del">
+          <ac:chgData name="Sam Khalil" userId="82cd1ec2-6208-465b-9d4d-40ce8f0cbf96" providerId="ADAL" clId="{87A27B4C-FB13-9545-B06C-83D288B68DDE}" dt="2025-08-15T06:50:27.733" v="168" actId="6264"/>
+          <ac:spMkLst>
+            <pc:docMk/>
+            <pc:sldMk cId="1648052740" sldId="256"/>
+            <ac:spMk id="15" creationId="{8DAB3A8B-70F1-EA5A-5BC4-979CC45FC424}"/>
+          </ac:spMkLst>
+        </pc:spChg>
+        <pc:spChg chg="add mod ord">
+          <ac:chgData name="Sam Khalil" userId="82cd1ec2-6208-465b-9d4d-40ce8f0cbf96" providerId="ADAL" clId="{87A27B4C-FB13-9545-B06C-83D288B68DDE}" dt="2025-08-15T06:49:26.247" v="161" actId="6264"/>
+          <ac:spMkLst>
+            <pc:docMk/>
+            <pc:sldMk cId="1648052740" sldId="256"/>
+            <ac:spMk id="16" creationId="{23B940EA-F342-EC15-1243-F4416A3A8AEF}"/>
+          </ac:spMkLst>
+        </pc:spChg>
+        <pc:spChg chg="add mod ord">
+          <ac:chgData name="Sam Khalil" userId="82cd1ec2-6208-465b-9d4d-40ce8f0cbf96" providerId="ADAL" clId="{87A27B4C-FB13-9545-B06C-83D288B68DDE}" dt="2025-08-15T06:49:26.247" v="161" actId="6264"/>
+          <ac:spMkLst>
+            <pc:docMk/>
+            <pc:sldMk cId="1648052740" sldId="256"/>
+            <ac:spMk id="18" creationId="{7F42291D-6622-BDEB-63FB-1E067E3CB578}"/>
+          </ac:spMkLst>
+        </pc:spChg>
+        <pc:spChg chg="add del mod ord">
+          <ac:chgData name="Sam Khalil" userId="82cd1ec2-6208-465b-9d4d-40ce8f0cbf96" providerId="ADAL" clId="{87A27B4C-FB13-9545-B06C-83D288B68DDE}" dt="2025-08-15T06:50:27.733" v="168" actId="6264"/>
+          <ac:spMkLst>
+            <pc:docMk/>
+            <pc:sldMk cId="1648052740" sldId="256"/>
+            <ac:spMk id="21" creationId="{694C3AE1-E430-9E8C-828A-FB1C8AA1C3ED}"/>
+          </ac:spMkLst>
+        </pc:spChg>
+        <pc:spChg chg="add mod ord">
+          <ac:chgData name="Sam Khalil" userId="82cd1ec2-6208-465b-9d4d-40ce8f0cbf96" providerId="ADAL" clId="{87A27B4C-FB13-9545-B06C-83D288B68DDE}" dt="2025-08-15T06:49:26.247" v="161" actId="6264"/>
+          <ac:spMkLst>
+            <pc:docMk/>
+            <pc:sldMk cId="1648052740" sldId="256"/>
+            <ac:spMk id="22" creationId="{AD48B8F8-C1A2-262E-3801-FEA37114A775}"/>
+          </ac:spMkLst>
+        </pc:spChg>
+        <pc:spChg chg="add mod ord">
+          <ac:chgData name="Sam Khalil" userId="82cd1ec2-6208-465b-9d4d-40ce8f0cbf96" providerId="ADAL" clId="{87A27B4C-FB13-9545-B06C-83D288B68DDE}" dt="2025-08-15T06:50:27.733" v="168" actId="6264"/>
+          <ac:spMkLst>
+            <pc:docMk/>
+            <pc:sldMk cId="1648052740" sldId="256"/>
+            <ac:spMk id="23" creationId="{61E76353-E036-6F06-CF99-D2FCDB0AF8E8}"/>
+          </ac:spMkLst>
+        </pc:spChg>
+        <pc:spChg chg="add mod ord">
+          <ac:chgData name="Sam Khalil" userId="82cd1ec2-6208-465b-9d4d-40ce8f0cbf96" providerId="ADAL" clId="{87A27B4C-FB13-9545-B06C-83D288B68DDE}" dt="2025-08-15T06:50:27.733" v="168" actId="6264"/>
+          <ac:spMkLst>
+            <pc:docMk/>
+            <pc:sldMk cId="1648052740" sldId="256"/>
+            <ac:spMk id="25" creationId="{046CDDD7-0048-80EB-574D-5F8B36E3B30F}"/>
+          </ac:spMkLst>
+        </pc:spChg>
+        <pc:spChg chg="add mod ord">
+          <ac:chgData name="Sam Khalil" userId="82cd1ec2-6208-465b-9d4d-40ce8f0cbf96" providerId="ADAL" clId="{87A27B4C-FB13-9545-B06C-83D288B68DDE}" dt="2025-08-15T06:50:27.733" v="168" actId="6264"/>
+          <ac:spMkLst>
+            <pc:docMk/>
+            <pc:sldMk cId="1648052740" sldId="256"/>
+            <ac:spMk id="30" creationId="{DF9FCC70-9393-D4B2-4B64-DBB1464EB82D}"/>
+          </ac:spMkLst>
+        </pc:spChg>
+        <pc:spChg chg="add mod ord">
+          <ac:chgData name="Sam Khalil" userId="82cd1ec2-6208-465b-9d4d-40ce8f0cbf96" providerId="ADAL" clId="{87A27B4C-FB13-9545-B06C-83D288B68DDE}" dt="2025-08-15T06:50:27.733" v="168" actId="6264"/>
+          <ac:spMkLst>
+            <pc:docMk/>
+            <pc:sldMk cId="1648052740" sldId="256"/>
+            <ac:spMk id="31" creationId="{323BF2FB-C319-AE66-13BD-9711EB0ADC79}"/>
+          </ac:spMkLst>
+        </pc:spChg>
+        <pc:spChg chg="add mod ord">
+          <ac:chgData name="Sam Khalil" userId="82cd1ec2-6208-465b-9d4d-40ce8f0cbf96" providerId="ADAL" clId="{87A27B4C-FB13-9545-B06C-83D288B68DDE}" dt="2025-08-15T06:50:27.733" v="168" actId="6264"/>
+          <ac:spMkLst>
+            <pc:docMk/>
+            <pc:sldMk cId="1648052740" sldId="256"/>
+            <ac:spMk id="32" creationId="{DAA4C212-5F3F-ECCC-35EE-A9C74201F0CC}"/>
+          </ac:spMkLst>
+        </pc:spChg>
+        <pc:spChg chg="add mod ord">
+          <ac:chgData name="Sam Khalil" userId="82cd1ec2-6208-465b-9d4d-40ce8f0cbf96" providerId="ADAL" clId="{87A27B4C-FB13-9545-B06C-83D288B68DDE}" dt="2025-08-15T06:50:27.733" v="168" actId="6264"/>
+          <ac:spMkLst>
+            <pc:docMk/>
+            <pc:sldMk cId="1648052740" sldId="256"/>
+            <ac:spMk id="33" creationId="{77B2C89C-BB96-FA69-DB86-DF56571A3D30}"/>
+          </ac:spMkLst>
+        </pc:spChg>
+      </pc:sldChg>
+      <pc:sldChg chg="addSp delSp modSp new del mod chgLayout">
+        <pc:chgData name="Sam Khalil" userId="82cd1ec2-6208-465b-9d4d-40ce8f0cbf96" providerId="ADAL" clId="{87A27B4C-FB13-9545-B06C-83D288B68DDE}" dt="2025-08-15T06:46:33.342" v="65" actId="2696"/>
+        <pc:sldMkLst>
+          <pc:docMk/>
+          <pc:sldMk cId="1792170806" sldId="256"/>
+        </pc:sldMkLst>
+        <pc:spChg chg="del">
+          <ac:chgData name="Sam Khalil" userId="82cd1ec2-6208-465b-9d4d-40ce8f0cbf96" providerId="ADAL" clId="{87A27B4C-FB13-9545-B06C-83D288B68DDE}" dt="2025-08-15T06:45:26.020" v="36" actId="6264"/>
+          <ac:spMkLst>
+            <pc:docMk/>
+            <pc:sldMk cId="1792170806" sldId="256"/>
+            <ac:spMk id="2" creationId="{C67E6E8C-C12D-2CB7-2920-B86B1759457C}"/>
+          </ac:spMkLst>
+        </pc:spChg>
+        <pc:spChg chg="del">
+          <ac:chgData name="Sam Khalil" userId="82cd1ec2-6208-465b-9d4d-40ce8f0cbf96" providerId="ADAL" clId="{87A27B4C-FB13-9545-B06C-83D288B68DDE}" dt="2025-08-15T06:45:26.020" v="36" actId="6264"/>
+          <ac:spMkLst>
+            <pc:docMk/>
+            <pc:sldMk cId="1792170806" sldId="256"/>
+            <ac:spMk id="4" creationId="{BBCD8C05-E909-8D66-CCC2-096B47301486}"/>
+          </ac:spMkLst>
+        </pc:spChg>
+        <pc:spChg chg="del">
+          <ac:chgData name="Sam Khalil" userId="82cd1ec2-6208-465b-9d4d-40ce8f0cbf96" providerId="ADAL" clId="{87A27B4C-FB13-9545-B06C-83D288B68DDE}" dt="2025-08-15T06:45:26.020" v="36" actId="6264"/>
+          <ac:spMkLst>
+            <pc:docMk/>
+            <pc:sldMk cId="1792170806" sldId="256"/>
+            <ac:spMk id="5" creationId="{E0CD6839-8B05-1614-FAE3-577B27D2C4E8}"/>
+          </ac:spMkLst>
+        </pc:spChg>
+        <pc:spChg chg="del">
+          <ac:chgData name="Sam Khalil" userId="82cd1ec2-6208-465b-9d4d-40ce8f0cbf96" providerId="ADAL" clId="{87A27B4C-FB13-9545-B06C-83D288B68DDE}" dt="2025-08-15T06:45:26.020" v="36" actId="6264"/>
+          <ac:spMkLst>
+            <pc:docMk/>
+            <pc:sldMk cId="1792170806" sldId="256"/>
+            <ac:spMk id="10" creationId="{209187A9-679D-690D-9FDA-AC61586E1574}"/>
+          </ac:spMkLst>
+        </pc:spChg>
+        <pc:spChg chg="del">
+          <ac:chgData name="Sam Khalil" userId="82cd1ec2-6208-465b-9d4d-40ce8f0cbf96" providerId="ADAL" clId="{87A27B4C-FB13-9545-B06C-83D288B68DDE}" dt="2025-08-15T06:45:26.020" v="36" actId="6264"/>
+          <ac:spMkLst>
+            <pc:docMk/>
+            <pc:sldMk cId="1792170806" sldId="256"/>
+            <ac:spMk id="11" creationId="{024AF0EE-F381-9B0B-6CDD-FE1E7C91F116}"/>
+          </ac:spMkLst>
+        </pc:spChg>
+        <pc:spChg chg="del">
+          <ac:chgData name="Sam Khalil" userId="82cd1ec2-6208-465b-9d4d-40ce8f0cbf96" providerId="ADAL" clId="{87A27B4C-FB13-9545-B06C-83D288B68DDE}" dt="2025-08-15T06:45:01.223" v="29" actId="478"/>
+          <ac:spMkLst>
+            <pc:docMk/>
+            <pc:sldMk cId="1792170806" sldId="256"/>
+            <ac:spMk id="12" creationId="{73A722CC-1E4D-BD52-8C50-1712B9FFE955}"/>
+          </ac:spMkLst>
+        </pc:spChg>
+        <pc:spChg chg="add del mod ord">
+          <ac:chgData name="Sam Khalil" userId="82cd1ec2-6208-465b-9d4d-40ce8f0cbf96" providerId="ADAL" clId="{87A27B4C-FB13-9545-B06C-83D288B68DDE}" dt="2025-08-15T06:46:19.226" v="54" actId="6264"/>
+          <ac:spMkLst>
+            <pc:docMk/>
+            <pc:sldMk cId="1792170806" sldId="256"/>
+            <ac:spMk id="15" creationId="{6B371498-7518-0F41-4E04-E5055E2730D0}"/>
+          </ac:spMkLst>
+        </pc:spChg>
+        <pc:spChg chg="add del mod ord">
+          <ac:chgData name="Sam Khalil" userId="82cd1ec2-6208-465b-9d4d-40ce8f0cbf96" providerId="ADAL" clId="{87A27B4C-FB13-9545-B06C-83D288B68DDE}" dt="2025-08-15T06:46:19.226" v="54" actId="6264"/>
+          <ac:spMkLst>
+            <pc:docMk/>
+            <pc:sldMk cId="1792170806" sldId="256"/>
+            <ac:spMk id="17" creationId="{602A82DA-705C-45C7-E876-4B35A5A42081}"/>
+          </ac:spMkLst>
+        </pc:spChg>
+        <pc:spChg chg="add del mod ord">
+          <ac:chgData name="Sam Khalil" userId="82cd1ec2-6208-465b-9d4d-40ce8f0cbf96" providerId="ADAL" clId="{87A27B4C-FB13-9545-B06C-83D288B68DDE}" dt="2025-08-15T06:46:19.226" v="54" actId="6264"/>
+          <ac:spMkLst>
+            <pc:docMk/>
+            <pc:sldMk cId="1792170806" sldId="256"/>
+            <ac:spMk id="18" creationId="{DE3203EB-5038-79FB-8468-AA287EB8B177}"/>
+          </ac:spMkLst>
+        </pc:spChg>
+        <pc:spChg chg="add del mod ord">
+          <ac:chgData name="Sam Khalil" userId="82cd1ec2-6208-465b-9d4d-40ce8f0cbf96" providerId="ADAL" clId="{87A27B4C-FB13-9545-B06C-83D288B68DDE}" dt="2025-08-15T06:46:19.226" v="54" actId="6264"/>
+          <ac:spMkLst>
+            <pc:docMk/>
+            <pc:sldMk cId="1792170806" sldId="256"/>
+            <ac:spMk id="19" creationId="{282CAE2E-C06E-9661-72D2-0D36F491E7D4}"/>
+          </ac:spMkLst>
+        </pc:spChg>
+        <pc:spChg chg="add del mod ord">
+          <ac:chgData name="Sam Khalil" userId="82cd1ec2-6208-465b-9d4d-40ce8f0cbf96" providerId="ADAL" clId="{87A27B4C-FB13-9545-B06C-83D288B68DDE}" dt="2025-08-15T06:46:19.226" v="54" actId="6264"/>
+          <ac:spMkLst>
+            <pc:docMk/>
+            <pc:sldMk cId="1792170806" sldId="256"/>
+            <ac:spMk id="20" creationId="{DE6E7402-6905-1647-6773-579994120985}"/>
+          </ac:spMkLst>
+        </pc:spChg>
+        <pc:spChg chg="add del mod ord">
+          <ac:chgData name="Sam Khalil" userId="82cd1ec2-6208-465b-9d4d-40ce8f0cbf96" providerId="ADAL" clId="{87A27B4C-FB13-9545-B06C-83D288B68DDE}" dt="2025-08-15T06:46:19.798" v="55" actId="6264"/>
+          <ac:spMkLst>
+            <pc:docMk/>
+            <pc:sldMk cId="1792170806" sldId="256"/>
+            <ac:spMk id="23" creationId="{03535595-2F46-04E6-70A2-B2DB9E3863E8}"/>
+          </ac:spMkLst>
+        </pc:spChg>
+        <pc:spChg chg="add del mod ord">
+          <ac:chgData name="Sam Khalil" userId="82cd1ec2-6208-465b-9d4d-40ce8f0cbf96" providerId="ADAL" clId="{87A27B4C-FB13-9545-B06C-83D288B68DDE}" dt="2025-08-15T06:46:19.798" v="55" actId="6264"/>
+          <ac:spMkLst>
+            <pc:docMk/>
+            <pc:sldMk cId="1792170806" sldId="256"/>
+            <ac:spMk id="28" creationId="{0956D505-72C5-AA6C-EF39-8FC9E1978389}"/>
+          </ac:spMkLst>
+        </pc:spChg>
+        <pc:spChg chg="add del mod ord">
+          <ac:chgData name="Sam Khalil" userId="82cd1ec2-6208-465b-9d4d-40ce8f0cbf96" providerId="ADAL" clId="{87A27B4C-FB13-9545-B06C-83D288B68DDE}" dt="2025-08-15T06:46:19.798" v="55" actId="6264"/>
+          <ac:spMkLst>
+            <pc:docMk/>
+            <pc:sldMk cId="1792170806" sldId="256"/>
+            <ac:spMk id="30" creationId="{29BF4643-2E5A-2A3F-1AF3-D78446129191}"/>
+          </ac:spMkLst>
+        </pc:spChg>
+        <pc:spChg chg="add del mod ord">
+          <ac:chgData name="Sam Khalil" userId="82cd1ec2-6208-465b-9d4d-40ce8f0cbf96" providerId="ADAL" clId="{87A27B4C-FB13-9545-B06C-83D288B68DDE}" dt="2025-08-15T06:46:19.798" v="55" actId="6264"/>
+          <ac:spMkLst>
+            <pc:docMk/>
+            <pc:sldMk cId="1792170806" sldId="256"/>
+            <ac:spMk id="31" creationId="{BAD433A1-9B6E-E6B7-3FDF-2C0665399BFD}"/>
+          </ac:spMkLst>
+        </pc:spChg>
+        <pc:spChg chg="add del mod ord">
+          <ac:chgData name="Sam Khalil" userId="82cd1ec2-6208-465b-9d4d-40ce8f0cbf96" providerId="ADAL" clId="{87A27B4C-FB13-9545-B06C-83D288B68DDE}" dt="2025-08-15T06:46:19.798" v="55" actId="6264"/>
+          <ac:spMkLst>
+            <pc:docMk/>
+            <pc:sldMk cId="1792170806" sldId="256"/>
+            <ac:spMk id="32" creationId="{A4343328-D8C2-AF69-45EA-84826DD142CD}"/>
+          </ac:spMkLst>
+        </pc:spChg>
+        <pc:spChg chg="add mod ord">
+          <ac:chgData name="Sam Khalil" userId="82cd1ec2-6208-465b-9d4d-40ce8f0cbf96" providerId="ADAL" clId="{87A27B4C-FB13-9545-B06C-83D288B68DDE}" dt="2025-08-15T06:46:21.674" v="64" actId="20577"/>
+          <ac:spMkLst>
+            <pc:docMk/>
+            <pc:sldMk cId="1792170806" sldId="256"/>
+            <ac:spMk id="35" creationId="{1ABA46E9-70EF-ED33-8364-89C9FC25A191}"/>
+          </ac:spMkLst>
+        </pc:spChg>
+        <pc:spChg chg="add mod ord">
+          <ac:chgData name="Sam Khalil" userId="82cd1ec2-6208-465b-9d4d-40ce8f0cbf96" providerId="ADAL" clId="{87A27B4C-FB13-9545-B06C-83D288B68DDE}" dt="2025-08-15T06:46:19.798" v="55" actId="6264"/>
+          <ac:spMkLst>
+            <pc:docMk/>
+            <pc:sldMk cId="1792170806" sldId="256"/>
+            <ac:spMk id="36" creationId="{757F9F4F-1895-BE3E-DD06-199F5C6FC939}"/>
+          </ac:spMkLst>
+        </pc:spChg>
+        <pc:spChg chg="add mod ord">
+          <ac:chgData name="Sam Khalil" userId="82cd1ec2-6208-465b-9d4d-40ce8f0cbf96" providerId="ADAL" clId="{87A27B4C-FB13-9545-B06C-83D288B68DDE}" dt="2025-08-15T06:46:19.798" v="55" actId="6264"/>
+          <ac:spMkLst>
+            <pc:docMk/>
+            <pc:sldMk cId="1792170806" sldId="256"/>
+            <ac:spMk id="40" creationId="{8113EF27-037A-2659-7850-D7B5FA008364}"/>
+          </ac:spMkLst>
+        </pc:spChg>
+        <pc:spChg chg="add mod ord">
+          <ac:chgData name="Sam Khalil" userId="82cd1ec2-6208-465b-9d4d-40ce8f0cbf96" providerId="ADAL" clId="{87A27B4C-FB13-9545-B06C-83D288B68DDE}" dt="2025-08-15T06:46:19.798" v="55" actId="6264"/>
+          <ac:spMkLst>
+            <pc:docMk/>
+            <pc:sldMk cId="1792170806" sldId="256"/>
+            <ac:spMk id="41" creationId="{29CDD00F-52AA-9861-140D-371E48393500}"/>
+          </ac:spMkLst>
+        </pc:spChg>
+        <pc:spChg chg="add mod ord">
+          <ac:chgData name="Sam Khalil" userId="82cd1ec2-6208-465b-9d4d-40ce8f0cbf96" providerId="ADAL" clId="{87A27B4C-FB13-9545-B06C-83D288B68DDE}" dt="2025-08-15T06:46:19.798" v="55" actId="6264"/>
+          <ac:spMkLst>
+            <pc:docMk/>
+            <pc:sldMk cId="1792170806" sldId="256"/>
+            <ac:spMk id="42" creationId="{F97C3A45-FC71-D261-0170-DEABDF4389FE}"/>
+          </ac:spMkLst>
+        </pc:spChg>
+      </pc:sldChg>
+      <pc:sldChg chg="new del">
+        <pc:chgData name="Sam Khalil" userId="82cd1ec2-6208-465b-9d4d-40ce8f0cbf96" providerId="ADAL" clId="{87A27B4C-FB13-9545-B06C-83D288B68DDE}" dt="2025-08-15T06:54:29.911" v="210" actId="2696"/>
+        <pc:sldMkLst>
+          <pc:docMk/>
+          <pc:sldMk cId="2725628606" sldId="256"/>
         </pc:sldMkLst>
       </pc:sldChg>
-      <pc:sldMasterChg chg="modSldLayout">
-        <pc:chgData name="Sam Khalil" userId="82cd1ec2-6208-465b-9d4d-40ce8f0cbf96" providerId="ADAL" clId="{85B83225-0F8B-4540-96C4-3916D224CEC7}" dt="2025-08-13T22:18:27.754" v="968"/>
+      <pc:sldChg chg="modSp new del mod">
+        <pc:chgData name="Sam Khalil" userId="82cd1ec2-6208-465b-9d4d-40ce8f0cbf96" providerId="ADAL" clId="{87A27B4C-FB13-9545-B06C-83D288B68DDE}" dt="2025-08-15T06:46:39.877" v="74" actId="680"/>
+        <pc:sldMkLst>
+          <pc:docMk/>
+          <pc:sldMk cId="2764626424" sldId="256"/>
+        </pc:sldMkLst>
+        <pc:spChg chg="mod">
+          <ac:chgData name="Sam Khalil" userId="82cd1ec2-6208-465b-9d4d-40ce8f0cbf96" providerId="ADAL" clId="{87A27B4C-FB13-9545-B06C-83D288B68DDE}" dt="2025-08-15T06:46:39.293" v="73" actId="20577"/>
+          <ac:spMkLst>
+            <pc:docMk/>
+            <pc:sldMk cId="2764626424" sldId="256"/>
+            <ac:spMk id="6" creationId="{63076F66-F469-B157-12BF-C4C1815F975F}"/>
+          </ac:spMkLst>
+        </pc:spChg>
+      </pc:sldChg>
+      <pc:sldChg chg="new del">
+        <pc:chgData name="Sam Khalil" userId="82cd1ec2-6208-465b-9d4d-40ce8f0cbf96" providerId="ADAL" clId="{87A27B4C-FB13-9545-B06C-83D288B68DDE}" dt="2025-08-15T06:54:47.035" v="212" actId="2696"/>
+        <pc:sldMkLst>
+          <pc:docMk/>
+          <pc:sldMk cId="2998353675" sldId="256"/>
+        </pc:sldMkLst>
+      </pc:sldChg>
+      <pc:sldChg chg="addSp delSp modSp del mod chgLayout">
+        <pc:chgData name="Sam Khalil" userId="82cd1ec2-6208-465b-9d4d-40ce8f0cbf96" providerId="ADAL" clId="{87A27B4C-FB13-9545-B06C-83D288B68DDE}" dt="2025-08-15T06:44:51.312" v="27" actId="2696"/>
+        <pc:sldMkLst>
+          <pc:docMk/>
+          <pc:sldMk cId="4142939850" sldId="256"/>
+        </pc:sldMkLst>
+        <pc:spChg chg="del">
+          <ac:chgData name="Sam Khalil" userId="82cd1ec2-6208-465b-9d4d-40ce8f0cbf96" providerId="ADAL" clId="{87A27B4C-FB13-9545-B06C-83D288B68DDE}" dt="2025-08-15T06:44:14.816" v="10" actId="6264"/>
+          <ac:spMkLst>
+            <pc:docMk/>
+            <pc:sldMk cId="4142939850" sldId="256"/>
+            <ac:spMk id="32" creationId="{77FF717B-A365-C8A9-1A8B-A33B2168DDBC}"/>
+          </ac:spMkLst>
+        </pc:spChg>
+        <pc:spChg chg="del">
+          <ac:chgData name="Sam Khalil" userId="82cd1ec2-6208-465b-9d4d-40ce8f0cbf96" providerId="ADAL" clId="{87A27B4C-FB13-9545-B06C-83D288B68DDE}" dt="2025-08-15T06:44:14.816" v="10" actId="6264"/>
+          <ac:spMkLst>
+            <pc:docMk/>
+            <pc:sldMk cId="4142939850" sldId="256"/>
+            <ac:spMk id="33" creationId="{AE170BFC-8AB9-2E53-9F6E-0185D51475A4}"/>
+          </ac:spMkLst>
+        </pc:spChg>
+        <pc:spChg chg="del">
+          <ac:chgData name="Sam Khalil" userId="82cd1ec2-6208-465b-9d4d-40ce8f0cbf96" providerId="ADAL" clId="{87A27B4C-FB13-9545-B06C-83D288B68DDE}" dt="2025-08-15T06:44:14.816" v="10" actId="6264"/>
+          <ac:spMkLst>
+            <pc:docMk/>
+            <pc:sldMk cId="4142939850" sldId="256"/>
+            <ac:spMk id="36" creationId="{7B01033A-56B4-C2D7-6977-324ADE2D49F1}"/>
+          </ac:spMkLst>
+        </pc:spChg>
+        <pc:spChg chg="del">
+          <ac:chgData name="Sam Khalil" userId="82cd1ec2-6208-465b-9d4d-40ce8f0cbf96" providerId="ADAL" clId="{87A27B4C-FB13-9545-B06C-83D288B68DDE}" dt="2025-08-15T06:44:14.816" v="10" actId="6264"/>
+          <ac:spMkLst>
+            <pc:docMk/>
+            <pc:sldMk cId="4142939850" sldId="256"/>
+            <ac:spMk id="38" creationId="{468E503E-073B-721C-0085-63EFED27BB49}"/>
+          </ac:spMkLst>
+        </pc:spChg>
+        <pc:spChg chg="del">
+          <ac:chgData name="Sam Khalil" userId="82cd1ec2-6208-465b-9d4d-40ce8f0cbf96" providerId="ADAL" clId="{87A27B4C-FB13-9545-B06C-83D288B68DDE}" dt="2025-08-15T06:44:14.816" v="10" actId="6264"/>
+          <ac:spMkLst>
+            <pc:docMk/>
+            <pc:sldMk cId="4142939850" sldId="256"/>
+            <ac:spMk id="41" creationId="{9B3547B2-D28B-279A-C84C-EBB3A000AED5}"/>
+          </ac:spMkLst>
+        </pc:spChg>
+        <pc:spChg chg="add mod ord">
+          <ac:chgData name="Sam Khalil" userId="82cd1ec2-6208-465b-9d4d-40ce8f0cbf96" providerId="ADAL" clId="{87A27B4C-FB13-9545-B06C-83D288B68DDE}" dt="2025-08-15T06:44:14.816" v="10" actId="6264"/>
+          <ac:spMkLst>
+            <pc:docMk/>
+            <pc:sldMk cId="4142939850" sldId="256"/>
+            <ac:spMk id="42" creationId="{23E31666-8E9A-0A8E-2364-B8493E93F161}"/>
+          </ac:spMkLst>
+        </pc:spChg>
+        <pc:spChg chg="mod">
+          <ac:chgData name="Sam Khalil" userId="82cd1ec2-6208-465b-9d4d-40ce8f0cbf96" providerId="ADAL" clId="{87A27B4C-FB13-9545-B06C-83D288B68DDE}" dt="2025-08-15T06:44:21.602" v="13" actId="20577"/>
+          <ac:spMkLst>
+            <pc:docMk/>
+            <pc:sldMk cId="4142939850" sldId="256"/>
+            <ac:spMk id="44" creationId="{97C47ECB-8E68-9E6C-3A13-92186F99CC09}"/>
+          </ac:spMkLst>
+        </pc:spChg>
+        <pc:spChg chg="add mod ord">
+          <ac:chgData name="Sam Khalil" userId="82cd1ec2-6208-465b-9d4d-40ce8f0cbf96" providerId="ADAL" clId="{87A27B4C-FB13-9545-B06C-83D288B68DDE}" dt="2025-08-15T06:44:14.816" v="10" actId="6264"/>
+          <ac:spMkLst>
+            <pc:docMk/>
+            <pc:sldMk cId="4142939850" sldId="256"/>
+            <ac:spMk id="46" creationId="{80C1EDBB-5C1A-2BFD-AC05-67921B446C94}"/>
+          </ac:spMkLst>
+        </pc:spChg>
+        <pc:spChg chg="add mod ord">
+          <ac:chgData name="Sam Khalil" userId="82cd1ec2-6208-465b-9d4d-40ce8f0cbf96" providerId="ADAL" clId="{87A27B4C-FB13-9545-B06C-83D288B68DDE}" dt="2025-08-15T06:44:14.816" v="10" actId="6264"/>
+          <ac:spMkLst>
+            <pc:docMk/>
+            <pc:sldMk cId="4142939850" sldId="256"/>
+            <ac:spMk id="47" creationId="{ED0B8E33-D837-E607-2150-6F0DEFD1B54E}"/>
+          </ac:spMkLst>
+        </pc:spChg>
+        <pc:spChg chg="add mod ord">
+          <ac:chgData name="Sam Khalil" userId="82cd1ec2-6208-465b-9d4d-40ce8f0cbf96" providerId="ADAL" clId="{87A27B4C-FB13-9545-B06C-83D288B68DDE}" dt="2025-08-15T06:44:14.816" v="10" actId="6264"/>
+          <ac:spMkLst>
+            <pc:docMk/>
+            <pc:sldMk cId="4142939850" sldId="256"/>
+            <ac:spMk id="48" creationId="{AE929820-3994-18DF-804A-5CEB35FED18F}"/>
+          </ac:spMkLst>
+        </pc:spChg>
+        <pc:spChg chg="add mod ord">
+          <ac:chgData name="Sam Khalil" userId="82cd1ec2-6208-465b-9d4d-40ce8f0cbf96" providerId="ADAL" clId="{87A27B4C-FB13-9545-B06C-83D288B68DDE}" dt="2025-08-15T06:44:14.816" v="10" actId="6264"/>
+          <ac:spMkLst>
+            <pc:docMk/>
+            <pc:sldMk cId="4142939850" sldId="256"/>
+            <ac:spMk id="51" creationId="{44BE65B4-A7F2-306E-33D4-9B5E94F06770}"/>
+          </ac:spMkLst>
+        </pc:spChg>
+        <pc:spChg chg="mod">
+          <ac:chgData name="Sam Khalil" userId="82cd1ec2-6208-465b-9d4d-40ce8f0cbf96" providerId="ADAL" clId="{87A27B4C-FB13-9545-B06C-83D288B68DDE}" dt="2025-08-15T06:44:45.718" v="26" actId="20577"/>
+          <ac:spMkLst>
+            <pc:docMk/>
+            <pc:sldMk cId="4142939850" sldId="256"/>
+            <ac:spMk id="52" creationId="{A0523708-32ED-1953-CE42-44A9276DF923}"/>
+          </ac:spMkLst>
+        </pc:spChg>
+      </pc:sldChg>
+      <pc:sldChg chg="new del">
+        <pc:chgData name="Sam Khalil" userId="82cd1ec2-6208-465b-9d4d-40ce8f0cbf96" providerId="ADAL" clId="{87A27B4C-FB13-9545-B06C-83D288B68DDE}" dt="2025-08-15T08:26:01.855" v="286" actId="2696"/>
+        <pc:sldMkLst>
+          <pc:docMk/>
+          <pc:sldMk cId="1967230728" sldId="257"/>
+        </pc:sldMkLst>
+      </pc:sldChg>
+      <pc:sldChg chg="addSp modSp new del mod modClrScheme chgLayout">
+        <pc:chgData name="Sam Khalil" userId="82cd1ec2-6208-465b-9d4d-40ce8f0cbf96" providerId="ADAL" clId="{87A27B4C-FB13-9545-B06C-83D288B68DDE}" dt="2025-08-15T08:47:02.950" v="289" actId="2696"/>
+        <pc:sldMkLst>
+          <pc:docMk/>
+          <pc:sldMk cId="4157823060" sldId="258"/>
+        </pc:sldMkLst>
+        <pc:spChg chg="add mod">
+          <ac:chgData name="Sam Khalil" userId="82cd1ec2-6208-465b-9d4d-40ce8f0cbf96" providerId="ADAL" clId="{87A27B4C-FB13-9545-B06C-83D288B68DDE}" dt="2025-08-15T08:25:24.022" v="285"/>
+          <ac:spMkLst>
+            <pc:docMk/>
+            <pc:sldMk cId="4157823060" sldId="258"/>
+            <ac:spMk id="2" creationId="{A398D0A9-A2B2-6EFC-3CED-953C505E43AE}"/>
+          </ac:spMkLst>
+        </pc:spChg>
+        <pc:spChg chg="add mod">
+          <ac:chgData name="Sam Khalil" userId="82cd1ec2-6208-465b-9d4d-40ce8f0cbf96" providerId="ADAL" clId="{87A27B4C-FB13-9545-B06C-83D288B68DDE}" dt="2025-08-15T08:25:24.022" v="285"/>
+          <ac:spMkLst>
+            <pc:docMk/>
+            <pc:sldMk cId="4157823060" sldId="258"/>
+            <ac:spMk id="3" creationId="{66AC9D6C-5F16-A1FC-BB10-37ABB7DE399A}"/>
+          </ac:spMkLst>
+        </pc:spChg>
+        <pc:spChg chg="add mod">
+          <ac:chgData name="Sam Khalil" userId="82cd1ec2-6208-465b-9d4d-40ce8f0cbf96" providerId="ADAL" clId="{87A27B4C-FB13-9545-B06C-83D288B68DDE}" dt="2025-08-15T08:25:24.022" v="285"/>
+          <ac:spMkLst>
+            <pc:docMk/>
+            <pc:sldMk cId="4157823060" sldId="258"/>
+            <ac:spMk id="5" creationId="{EBBA909B-69E0-F165-22F3-25F1C7444665}"/>
+          </ac:spMkLst>
+        </pc:spChg>
+        <pc:spChg chg="add mod">
+          <ac:chgData name="Sam Khalil" userId="82cd1ec2-6208-465b-9d4d-40ce8f0cbf96" providerId="ADAL" clId="{87A27B4C-FB13-9545-B06C-83D288B68DDE}" dt="2025-08-15T08:25:24.022" v="285"/>
+          <ac:spMkLst>
+            <pc:docMk/>
+            <pc:sldMk cId="4157823060" sldId="258"/>
+            <ac:spMk id="6" creationId="{EF1DD8C4-B6B4-AF7A-FFB6-7FBFAE7F26E3}"/>
+          </ac:spMkLst>
+        </pc:spChg>
+        <pc:spChg chg="add mod">
+          <ac:chgData name="Sam Khalil" userId="82cd1ec2-6208-465b-9d4d-40ce8f0cbf96" providerId="ADAL" clId="{87A27B4C-FB13-9545-B06C-83D288B68DDE}" dt="2025-08-15T08:25:24.022" v="285"/>
+          <ac:spMkLst>
+            <pc:docMk/>
+            <pc:sldMk cId="4157823060" sldId="258"/>
+            <ac:spMk id="7" creationId="{483754B9-892F-973D-3AE9-48FDB9FF4EF2}"/>
+          </ac:spMkLst>
+        </pc:spChg>
+        <pc:spChg chg="add mod">
+          <ac:chgData name="Sam Khalil" userId="82cd1ec2-6208-465b-9d4d-40ce8f0cbf96" providerId="ADAL" clId="{87A27B4C-FB13-9545-B06C-83D288B68DDE}" dt="2025-08-15T08:25:24.022" v="285"/>
+          <ac:spMkLst>
+            <pc:docMk/>
+            <pc:sldMk cId="4157823060" sldId="258"/>
+            <ac:spMk id="8" creationId="{EA0BE010-2CC2-035C-E4F3-7CC76628D628}"/>
+          </ac:spMkLst>
+        </pc:spChg>
+        <pc:spChg chg="add mod">
+          <ac:chgData name="Sam Khalil" userId="82cd1ec2-6208-465b-9d4d-40ce8f0cbf96" providerId="ADAL" clId="{87A27B4C-FB13-9545-B06C-83D288B68DDE}" dt="2025-08-15T08:25:24.022" v="285"/>
+          <ac:spMkLst>
+            <pc:docMk/>
+            <pc:sldMk cId="4157823060" sldId="258"/>
+            <ac:spMk id="9" creationId="{57997299-39FD-6330-E94E-4EA0D902303A}"/>
+          </ac:spMkLst>
+        </pc:spChg>
+        <pc:spChg chg="add mod">
+          <ac:chgData name="Sam Khalil" userId="82cd1ec2-6208-465b-9d4d-40ce8f0cbf96" providerId="ADAL" clId="{87A27B4C-FB13-9545-B06C-83D288B68DDE}" dt="2025-08-15T08:25:24.022" v="285"/>
+          <ac:spMkLst>
+            <pc:docMk/>
+            <pc:sldMk cId="4157823060" sldId="258"/>
+            <ac:spMk id="10" creationId="{495D33E6-E8D1-4CBA-E973-88E605A05DDF}"/>
+          </ac:spMkLst>
+        </pc:spChg>
+        <pc:spChg chg="add mod">
+          <ac:chgData name="Sam Khalil" userId="82cd1ec2-6208-465b-9d4d-40ce8f0cbf96" providerId="ADAL" clId="{87A27B4C-FB13-9545-B06C-83D288B68DDE}" dt="2025-08-15T08:25:24.022" v="285"/>
+          <ac:spMkLst>
+            <pc:docMk/>
+            <pc:sldMk cId="4157823060" sldId="258"/>
+            <ac:spMk id="11" creationId="{65BF7AEE-B032-499C-5A17-8CB157208C57}"/>
+          </ac:spMkLst>
+        </pc:spChg>
+        <pc:spChg chg="add mod">
+          <ac:chgData name="Sam Khalil" userId="82cd1ec2-6208-465b-9d4d-40ce8f0cbf96" providerId="ADAL" clId="{87A27B4C-FB13-9545-B06C-83D288B68DDE}" dt="2025-08-15T08:25:24.022" v="285"/>
+          <ac:spMkLst>
+            <pc:docMk/>
+            <pc:sldMk cId="4157823060" sldId="258"/>
+            <ac:spMk id="12" creationId="{B2B5B29E-2ED7-5482-BC37-FA012CEC2CF9}"/>
+          </ac:spMkLst>
+        </pc:spChg>
+      </pc:sldChg>
+      <pc:sldChg chg="new del">
+        <pc:chgData name="Sam Khalil" userId="82cd1ec2-6208-465b-9d4d-40ce8f0cbf96" providerId="ADAL" clId="{87A27B4C-FB13-9545-B06C-83D288B68DDE}" dt="2025-08-15T08:47:03.379" v="290" actId="2696"/>
+        <pc:sldMkLst>
+          <pc:docMk/>
+          <pc:sldMk cId="3308701453" sldId="259"/>
+        </pc:sldMkLst>
+      </pc:sldChg>
+      <pc:sldMasterChg chg="delSp mod modSldLayout">
+        <pc:chgData name="Sam Khalil" userId="82cd1ec2-6208-465b-9d4d-40ce8f0cbf96" providerId="ADAL" clId="{87A27B4C-FB13-9545-B06C-83D288B68DDE}" dt="2025-08-15T08:25:16.413" v="283" actId="478"/>
         <pc:sldMasterMkLst>
           <pc:docMk/>
           <pc:sldMasterMk cId="3143898779" sldId="2147483768"/>
         </pc:sldMasterMkLst>
+        <pc:spChg chg="del">
+          <ac:chgData name="Sam Khalil" userId="82cd1ec2-6208-465b-9d4d-40ce8f0cbf96" providerId="ADAL" clId="{87A27B4C-FB13-9545-B06C-83D288B68DDE}" dt="2025-08-15T06:49:52.437" v="162" actId="478"/>
+          <ac:spMkLst>
+            <pc:docMk/>
+            <pc:sldMasterMk cId="3143898779" sldId="2147483768"/>
+            <ac:spMk id="2" creationId="{EA6FF0E5-BDE0-15F8-7060-A21C0F884A64}"/>
+          </ac:spMkLst>
+        </pc:spChg>
+        <pc:spChg chg="del">
+          <ac:chgData name="Sam Khalil" userId="82cd1ec2-6208-465b-9d4d-40ce8f0cbf96" providerId="ADAL" clId="{87A27B4C-FB13-9545-B06C-83D288B68DDE}" dt="2025-08-15T06:49:52.437" v="162" actId="478"/>
+          <ac:spMkLst>
+            <pc:docMk/>
+            <pc:sldMasterMk cId="3143898779" sldId="2147483768"/>
+            <ac:spMk id="3" creationId="{CDC7ED30-1FDC-AC4A-3B21-58493651C698}"/>
+          </ac:spMkLst>
+        </pc:spChg>
+        <pc:spChg chg="del">
+          <ac:chgData name="Sam Khalil" userId="82cd1ec2-6208-465b-9d4d-40ce8f0cbf96" providerId="ADAL" clId="{87A27B4C-FB13-9545-B06C-83D288B68DDE}" dt="2025-08-15T06:49:52.437" v="162" actId="478"/>
+          <ac:spMkLst>
+            <pc:docMk/>
+            <pc:sldMasterMk cId="3143898779" sldId="2147483768"/>
+            <ac:spMk id="5" creationId="{D302BDA8-8E35-A751-E48E-2A036DEB49CC}"/>
+          </ac:spMkLst>
+        </pc:spChg>
+        <pc:spChg chg="del">
+          <ac:chgData name="Sam Khalil" userId="82cd1ec2-6208-465b-9d4d-40ce8f0cbf96" providerId="ADAL" clId="{87A27B4C-FB13-9545-B06C-83D288B68DDE}" dt="2025-08-15T06:49:52.437" v="162" actId="478"/>
+          <ac:spMkLst>
+            <pc:docMk/>
+            <pc:sldMasterMk cId="3143898779" sldId="2147483768"/>
+            <ac:spMk id="6" creationId="{9D81B007-56E3-7E0C-8BD1-071F5CD56F3F}"/>
+          </ac:spMkLst>
+        </pc:spChg>
+        <pc:spChg chg="del">
+          <ac:chgData name="Sam Khalil" userId="82cd1ec2-6208-465b-9d4d-40ce8f0cbf96" providerId="ADAL" clId="{87A27B4C-FB13-9545-B06C-83D288B68DDE}" dt="2025-08-15T06:49:52.437" v="162" actId="478"/>
+          <ac:spMkLst>
+            <pc:docMk/>
+            <pc:sldMasterMk cId="3143898779" sldId="2147483768"/>
+            <ac:spMk id="7" creationId="{DABD1B5A-1014-6049-C8F1-D8B5C4A95EC4}"/>
+          </ac:spMkLst>
+        </pc:spChg>
+        <pc:spChg chg="del">
+          <ac:chgData name="Sam Khalil" userId="82cd1ec2-6208-465b-9d4d-40ce8f0cbf96" providerId="ADAL" clId="{87A27B4C-FB13-9545-B06C-83D288B68DDE}" dt="2025-08-15T06:49:52.437" v="162" actId="478"/>
+          <ac:spMkLst>
+            <pc:docMk/>
+            <pc:sldMasterMk cId="3143898779" sldId="2147483768"/>
+            <ac:spMk id="8" creationId="{B30FC3E5-7364-2F15-F71C-F375E843AA0A}"/>
+          </ac:spMkLst>
+        </pc:spChg>
+        <pc:spChg chg="del">
+          <ac:chgData name="Sam Khalil" userId="82cd1ec2-6208-465b-9d4d-40ce8f0cbf96" providerId="ADAL" clId="{87A27B4C-FB13-9545-B06C-83D288B68DDE}" dt="2025-08-15T06:49:52.437" v="162" actId="478"/>
+          <ac:spMkLst>
+            <pc:docMk/>
+            <pc:sldMasterMk cId="3143898779" sldId="2147483768"/>
+            <ac:spMk id="9" creationId="{5C322715-4D0A-5A83-0B34-9A206E5E1837}"/>
+          </ac:spMkLst>
+        </pc:spChg>
+        <pc:spChg chg="del">
+          <ac:chgData name="Sam Khalil" userId="82cd1ec2-6208-465b-9d4d-40ce8f0cbf96" providerId="ADAL" clId="{87A27B4C-FB13-9545-B06C-83D288B68DDE}" dt="2025-08-15T06:49:52.437" v="162" actId="478"/>
+          <ac:spMkLst>
+            <pc:docMk/>
+            <pc:sldMasterMk cId="3143898779" sldId="2147483768"/>
+            <ac:spMk id="10" creationId="{A77570E0-7F51-F55B-3B03-01CCCB12BE3F}"/>
+          </ac:spMkLst>
+        </pc:spChg>
+        <pc:spChg chg="del">
+          <ac:chgData name="Sam Khalil" userId="82cd1ec2-6208-465b-9d4d-40ce8f0cbf96" providerId="ADAL" clId="{87A27B4C-FB13-9545-B06C-83D288B68DDE}" dt="2025-08-15T06:49:52.437" v="162" actId="478"/>
+          <ac:spMkLst>
+            <pc:docMk/>
+            <pc:sldMasterMk cId="3143898779" sldId="2147483768"/>
+            <ac:spMk id="11" creationId="{90150168-1DB4-3F5B-036D-420D1AF2D477}"/>
+          </ac:spMkLst>
+        </pc:spChg>
+        <pc:spChg chg="del">
+          <ac:chgData name="Sam Khalil" userId="82cd1ec2-6208-465b-9d4d-40ce8f0cbf96" providerId="ADAL" clId="{87A27B4C-FB13-9545-B06C-83D288B68DDE}" dt="2025-08-15T06:49:52.437" v="162" actId="478"/>
+          <ac:spMkLst>
+            <pc:docMk/>
+            <pc:sldMasterMk cId="3143898779" sldId="2147483768"/>
+            <ac:spMk id="12" creationId="{D9C9A476-FD18-7D48-420C-12DE49F02BA5}"/>
+          </ac:spMkLst>
+        </pc:spChg>
         <pc:sldLayoutChg chg="addSp delSp modSp mod">
-          <pc:chgData name="Sam Khalil" userId="82cd1ec2-6208-465b-9d4d-40ce8f0cbf96" providerId="ADAL" clId="{85B83225-0F8B-4540-96C4-3916D224CEC7}" dt="2025-08-13T22:18:27.754" v="968"/>
+          <pc:chgData name="Sam Khalil" userId="82cd1ec2-6208-465b-9d4d-40ce8f0cbf96" providerId="ADAL" clId="{87A27B4C-FB13-9545-B06C-83D288B68DDE}" dt="2025-08-15T08:09:57.070" v="277" actId="20577"/>
           <pc:sldLayoutMkLst>
             <pc:docMk/>
             <pc:sldMasterMk cId="3143898779" sldId="2147483768"/>
             <pc:sldLayoutMk cId="1278989944" sldId="2147483769"/>
           </pc:sldLayoutMkLst>
           <pc:spChg chg="add del">
-            <ac:chgData name="Sam Khalil" userId="82cd1ec2-6208-465b-9d4d-40ce8f0cbf96" providerId="ADAL" clId="{85B83225-0F8B-4540-96C4-3916D224CEC7}" dt="2025-08-13T20:36:42.277" v="8" actId="11529"/>
+            <ac:chgData name="Sam Khalil" userId="82cd1ec2-6208-465b-9d4d-40ce8f0cbf96" providerId="ADAL" clId="{87A27B4C-FB13-9545-B06C-83D288B68DDE}" dt="2025-08-15T06:43:53.091" v="0" actId="11529"/>
             <ac:spMkLst>
               <pc:docMk/>
               <pc:sldMasterMk cId="3143898779" sldId="2147483768"/>
               <pc:sldLayoutMk cId="1278989944" sldId="2147483769"/>
-              <ac:spMk id="4" creationId="{661E5ED5-CC8D-6584-23D2-4547D7AFAD6C}"/>
+              <ac:spMk id="2" creationId="{697EEFF3-0D50-EE53-A476-944E348812F3}"/>
             </ac:spMkLst>
           </pc:spChg>
-          <pc:spChg chg="add mod ord">
-            <ac:chgData name="Sam Khalil" userId="82cd1ec2-6208-465b-9d4d-40ce8f0cbf96" providerId="ADAL" clId="{85B83225-0F8B-4540-96C4-3916D224CEC7}" dt="2025-08-13T20:59:43.749" v="506" actId="13244"/>
+          <pc:spChg chg="add del mod">
+            <ac:chgData name="Sam Khalil" userId="82cd1ec2-6208-465b-9d4d-40ce8f0cbf96" providerId="ADAL" clId="{87A27B4C-FB13-9545-B06C-83D288B68DDE}" dt="2025-08-15T06:45:07.880" v="30" actId="478"/>
+            <ac:spMkLst>
+              <pc:docMk/>
+              <pc:sldMasterMk cId="3143898779" sldId="2147483768"/>
+              <pc:sldLayoutMk cId="1278989944" sldId="2147483769"/>
+              <ac:spMk id="3" creationId="{209BD688-0614-F099-57E5-614199ECA8F4}"/>
+            </ac:spMkLst>
+          </pc:spChg>
+          <pc:spChg chg="add del">
+            <ac:chgData name="Sam Khalil" userId="82cd1ec2-6208-465b-9d4d-40ce8f0cbf96" providerId="ADAL" clId="{87A27B4C-FB13-9545-B06C-83D288B68DDE}" dt="2025-08-15T06:48:57.278" v="139" actId="11529"/>
+            <ac:spMkLst>
+              <pc:docMk/>
+              <pc:sldMasterMk cId="3143898779" sldId="2147483768"/>
+              <pc:sldLayoutMk cId="1278989944" sldId="2147483769"/>
+              <ac:spMk id="4" creationId="{1FE55C76-7951-BA21-904E-AD04B9C560DA}"/>
+            </ac:spMkLst>
+          </pc:spChg>
+          <pc:spChg chg="del mod">
+            <ac:chgData name="Sam Khalil" userId="82cd1ec2-6208-465b-9d4d-40ce8f0cbf96" providerId="ADAL" clId="{87A27B4C-FB13-9545-B06C-83D288B68DDE}" dt="2025-08-15T06:53:04.976" v="206" actId="478"/>
             <ac:spMkLst>
               <pc:docMk/>
               <pc:sldMasterMk cId="3143898779" sldId="2147483768"/>
@@ -170,17 +851,17 @@
               <ac:spMk id="5" creationId="{76F7200D-FEA1-CF69-A14D-E72026F4494E}"/>
             </ac:spMkLst>
           </pc:spChg>
-          <pc:spChg chg="add del">
-            <ac:chgData name="Sam Khalil" userId="82cd1ec2-6208-465b-9d4d-40ce8f0cbf96" providerId="ADAL" clId="{85B83225-0F8B-4540-96C4-3916D224CEC7}" dt="2025-08-13T20:39:47.656" v="66" actId="11529"/>
+          <pc:spChg chg="add mod">
+            <ac:chgData name="Sam Khalil" userId="82cd1ec2-6208-465b-9d4d-40ce8f0cbf96" providerId="ADAL" clId="{87A27B4C-FB13-9545-B06C-83D288B68DDE}" dt="2025-08-15T08:09:57.070" v="277" actId="20577"/>
             <ac:spMkLst>
               <pc:docMk/>
               <pc:sldMasterMk cId="3143898779" sldId="2147483768"/>
               <pc:sldLayoutMk cId="1278989944" sldId="2147483769"/>
-              <ac:spMk id="6" creationId="{9C4F5564-917F-85A7-845A-EEE3A85726FA}"/>
+              <ac:spMk id="6" creationId="{4159A364-144D-E2C8-29D6-EE565EC808D9}"/>
             </ac:spMkLst>
           </pc:spChg>
-          <pc:spChg chg="add mod">
-            <ac:chgData name="Sam Khalil" userId="82cd1ec2-6208-465b-9d4d-40ce8f0cbf96" providerId="ADAL" clId="{85B83225-0F8B-4540-96C4-3916D224CEC7}" dt="2025-08-13T20:59:10.955" v="499" actId="962"/>
+          <pc:spChg chg="mod">
+            <ac:chgData name="Sam Khalil" userId="82cd1ec2-6208-465b-9d4d-40ce8f0cbf96" providerId="ADAL" clId="{87A27B4C-FB13-9545-B06C-83D288B68DDE}" dt="2025-08-15T06:51:07.822" v="185" actId="207"/>
             <ac:spMkLst>
               <pc:docMk/>
               <pc:sldMasterMk cId="3143898779" sldId="2147483768"/>
@@ -188,26 +869,8 @@
               <ac:spMk id="8" creationId="{A2FFFB26-B15C-ACA5-E78C-496FA500C16C}"/>
             </ac:spMkLst>
           </pc:spChg>
-          <pc:spChg chg="add del">
-            <ac:chgData name="Sam Khalil" userId="82cd1ec2-6208-465b-9d4d-40ce8f0cbf96" providerId="ADAL" clId="{85B83225-0F8B-4540-96C4-3916D224CEC7}" dt="2025-08-13T20:42:05.628" v="109" actId="11529"/>
-            <ac:spMkLst>
-              <pc:docMk/>
-              <pc:sldMasterMk cId="3143898779" sldId="2147483768"/>
-              <pc:sldLayoutMk cId="1278989944" sldId="2147483769"/>
-              <ac:spMk id="9" creationId="{3C107CE7-3F91-9AEA-0E8A-DC1F336C3B64}"/>
-            </ac:spMkLst>
-          </pc:spChg>
-          <pc:spChg chg="mod ord modVis">
-            <ac:chgData name="Sam Khalil" userId="82cd1ec2-6208-465b-9d4d-40ce8f0cbf96" providerId="ADAL" clId="{85B83225-0F8B-4540-96C4-3916D224CEC7}" dt="2025-08-13T22:18:27.754" v="968"/>
-            <ac:spMkLst>
-              <pc:docMk/>
-              <pc:sldMasterMk cId="3143898779" sldId="2147483768"/>
-              <pc:sldLayoutMk cId="1278989944" sldId="2147483769"/>
-              <ac:spMk id="10" creationId="{0D21AAC8-19DB-3316-4B21-A1B0282F59B9}"/>
-            </ac:spMkLst>
-          </pc:spChg>
-          <pc:spChg chg="add mod ord">
-            <ac:chgData name="Sam Khalil" userId="82cd1ec2-6208-465b-9d4d-40ce8f0cbf96" providerId="ADAL" clId="{85B83225-0F8B-4540-96C4-3916D224CEC7}" dt="2025-08-13T20:59:41.779" v="505" actId="13244"/>
+          <pc:spChg chg="mod">
+            <ac:chgData name="Sam Khalil" userId="82cd1ec2-6208-465b-9d4d-40ce8f0cbf96" providerId="ADAL" clId="{87A27B4C-FB13-9545-B06C-83D288B68DDE}" dt="2025-08-15T06:50:23.237" v="167" actId="207"/>
             <ac:spMkLst>
               <pc:docMk/>
               <pc:sldMasterMk cId="3143898779" sldId="2147483768"/>
@@ -215,8 +878,8 @@
               <ac:spMk id="11" creationId="{2557F4C1-C905-3C2C-355C-D3BA9A571954}"/>
             </ac:spMkLst>
           </pc:spChg>
-          <pc:spChg chg="add mod">
-            <ac:chgData name="Sam Khalil" userId="82cd1ec2-6208-465b-9d4d-40ce8f0cbf96" providerId="ADAL" clId="{85B83225-0F8B-4540-96C4-3916D224CEC7}" dt="2025-08-13T22:13:58.863" v="958" actId="404"/>
+          <pc:spChg chg="mod">
+            <ac:chgData name="Sam Khalil" userId="82cd1ec2-6208-465b-9d4d-40ce8f0cbf96" providerId="ADAL" clId="{87A27B4C-FB13-9545-B06C-83D288B68DDE}" dt="2025-08-15T06:51:24.658" v="188" actId="207"/>
             <ac:spMkLst>
               <pc:docMk/>
               <pc:sldMasterMk cId="3143898779" sldId="2147483768"/>
@@ -224,44 +887,8 @@
               <ac:spMk id="12" creationId="{E22C6CA3-7193-4BFE-7A57-8BC551B9AF1A}"/>
             </ac:spMkLst>
           </pc:spChg>
-          <pc:spChg chg="mod ord modVis">
-            <ac:chgData name="Sam Khalil" userId="82cd1ec2-6208-465b-9d4d-40ce8f0cbf96" providerId="ADAL" clId="{85B83225-0F8B-4540-96C4-3916D224CEC7}" dt="2025-08-13T22:18:21.398" v="967" actId="167"/>
-            <ac:spMkLst>
-              <pc:docMk/>
-              <pc:sldMasterMk cId="3143898779" sldId="2147483768"/>
-              <pc:sldLayoutMk cId="1278989944" sldId="2147483769"/>
-              <ac:spMk id="13" creationId="{2842576F-3D11-F420-4B0A-1CDF85B9BFF4}"/>
-            </ac:spMkLst>
-          </pc:spChg>
-          <pc:spChg chg="add del mod">
-            <ac:chgData name="Sam Khalil" userId="82cd1ec2-6208-465b-9d4d-40ce8f0cbf96" providerId="ADAL" clId="{85B83225-0F8B-4540-96C4-3916D224CEC7}" dt="2025-08-13T20:53:19.803" v="371" actId="478"/>
-            <ac:spMkLst>
-              <pc:docMk/>
-              <pc:sldMasterMk cId="3143898779" sldId="2147483768"/>
-              <pc:sldLayoutMk cId="1278989944" sldId="2147483769"/>
-              <ac:spMk id="14" creationId="{D856A7A8-D410-2BC1-7B20-44378D2E9139}"/>
-            </ac:spMkLst>
-          </pc:spChg>
-          <pc:spChg chg="add del mod">
-            <ac:chgData name="Sam Khalil" userId="82cd1ec2-6208-465b-9d4d-40ce8f0cbf96" providerId="ADAL" clId="{85B83225-0F8B-4540-96C4-3916D224CEC7}" dt="2025-08-13T20:54:25.232" v="420" actId="478"/>
-            <ac:spMkLst>
-              <pc:docMk/>
-              <pc:sldMasterMk cId="3143898779" sldId="2147483768"/>
-              <pc:sldLayoutMk cId="1278989944" sldId="2147483769"/>
-              <ac:spMk id="15" creationId="{A0F789C6-A368-FE0F-6AE3-FA071B8B6E62}"/>
-            </ac:spMkLst>
-          </pc:spChg>
-          <pc:spChg chg="add del">
-            <ac:chgData name="Sam Khalil" userId="82cd1ec2-6208-465b-9d4d-40ce8f0cbf96" providerId="ADAL" clId="{85B83225-0F8B-4540-96C4-3916D224CEC7}" dt="2025-08-13T20:53:02.547" v="359" actId="11529"/>
-            <ac:spMkLst>
-              <pc:docMk/>
-              <pc:sldMasterMk cId="3143898779" sldId="2147483768"/>
-              <pc:sldLayoutMk cId="1278989944" sldId="2147483769"/>
-              <ac:spMk id="16" creationId="{5ABC8626-4007-DB7F-961D-A0529422CD59}"/>
-            </ac:spMkLst>
-          </pc:spChg>
-          <pc:spChg chg="add mod ord">
-            <ac:chgData name="Sam Khalil" userId="82cd1ec2-6208-465b-9d4d-40ce8f0cbf96" providerId="ADAL" clId="{85B83225-0F8B-4540-96C4-3916D224CEC7}" dt="2025-08-13T20:58:25.468" v="492" actId="13244"/>
+          <pc:spChg chg="mod">
+            <ac:chgData name="Sam Khalil" userId="82cd1ec2-6208-465b-9d4d-40ce8f0cbf96" providerId="ADAL" clId="{87A27B4C-FB13-9545-B06C-83D288B68DDE}" dt="2025-08-15T06:52:35.626" v="193" actId="255"/>
             <ac:spMkLst>
               <pc:docMk/>
               <pc:sldMasterMk cId="3143898779" sldId="2147483768"/>
@@ -269,80 +896,8 @@
               <ac:spMk id="17" creationId="{699C0282-F5CA-FEC9-C27B-CBCF39B8806F}"/>
             </ac:spMkLst>
           </pc:spChg>
-          <pc:spChg chg="add del">
-            <ac:chgData name="Sam Khalil" userId="82cd1ec2-6208-465b-9d4d-40ce8f0cbf96" providerId="ADAL" clId="{85B83225-0F8B-4540-96C4-3916D224CEC7}" dt="2025-08-13T20:54:32.159" v="421" actId="11529"/>
-            <ac:spMkLst>
-              <pc:docMk/>
-              <pc:sldMasterMk cId="3143898779" sldId="2147483768"/>
-              <pc:sldLayoutMk cId="1278989944" sldId="2147483769"/>
-              <ac:spMk id="18" creationId="{53ACA522-2301-E316-7812-F92C787717D2}"/>
-            </ac:spMkLst>
-          </pc:spChg>
-          <pc:spChg chg="add del mod">
-            <ac:chgData name="Sam Khalil" userId="82cd1ec2-6208-465b-9d4d-40ce8f0cbf96" providerId="ADAL" clId="{85B83225-0F8B-4540-96C4-3916D224CEC7}" dt="2025-08-13T20:57:56.354" v="489" actId="478"/>
-            <ac:spMkLst>
-              <pc:docMk/>
-              <pc:sldMasterMk cId="3143898779" sldId="2147483768"/>
-              <pc:sldLayoutMk cId="1278989944" sldId="2147483769"/>
-              <ac:spMk id="19" creationId="{E6BA84A7-814D-3D18-4B46-57E3251BDBC7}"/>
-            </ac:spMkLst>
-          </pc:spChg>
-          <pc:spChg chg="add del">
-            <ac:chgData name="Sam Khalil" userId="82cd1ec2-6208-465b-9d4d-40ce8f0cbf96" providerId="ADAL" clId="{85B83225-0F8B-4540-96C4-3916D224CEC7}" dt="2025-08-13T20:56:08.630" v="456" actId="11529"/>
-            <ac:spMkLst>
-              <pc:docMk/>
-              <pc:sldMasterMk cId="3143898779" sldId="2147483768"/>
-              <pc:sldLayoutMk cId="1278989944" sldId="2147483769"/>
-              <ac:spMk id="20" creationId="{99455E68-5456-9A9D-FD2E-C8619CDEFEB8}"/>
-            </ac:spMkLst>
-          </pc:spChg>
-          <pc:spChg chg="add mod">
-            <ac:chgData name="Sam Khalil" userId="82cd1ec2-6208-465b-9d4d-40ce8f0cbf96" providerId="ADAL" clId="{85B83225-0F8B-4540-96C4-3916D224CEC7}" dt="2025-08-13T20:58:33.119" v="494" actId="962"/>
-            <ac:spMkLst>
-              <pc:docMk/>
-              <pc:sldMasterMk cId="3143898779" sldId="2147483768"/>
-              <pc:sldLayoutMk cId="1278989944" sldId="2147483769"/>
-              <ac:spMk id="21" creationId="{40B0093E-4753-B8F8-55CD-6BD7B86A3733}"/>
-            </ac:spMkLst>
-          </pc:spChg>
-          <pc:spChg chg="add del">
-            <ac:chgData name="Sam Khalil" userId="82cd1ec2-6208-465b-9d4d-40ce8f0cbf96" providerId="ADAL" clId="{85B83225-0F8B-4540-96C4-3916D224CEC7}" dt="2025-08-13T21:00:40.593" v="508" actId="11529"/>
-            <ac:spMkLst>
-              <pc:docMk/>
-              <pc:sldMasterMk cId="3143898779" sldId="2147483768"/>
-              <pc:sldLayoutMk cId="1278989944" sldId="2147483769"/>
-              <ac:spMk id="22" creationId="{24AFB75F-6336-D433-B1F2-4C4AEF8DD954}"/>
-            </ac:spMkLst>
-          </pc:spChg>
-          <pc:spChg chg="add mod ord">
-            <ac:chgData name="Sam Khalil" userId="82cd1ec2-6208-465b-9d4d-40ce8f0cbf96" providerId="ADAL" clId="{85B83225-0F8B-4540-96C4-3916D224CEC7}" dt="2025-08-13T22:17:27.213" v="962" actId="20577"/>
-            <ac:spMkLst>
-              <pc:docMk/>
-              <pc:sldMasterMk cId="3143898779" sldId="2147483768"/>
-              <pc:sldLayoutMk cId="1278989944" sldId="2147483769"/>
-              <ac:spMk id="23" creationId="{6E8254B4-6EB0-45F2-EE30-CA1AF56F8AE8}"/>
-            </ac:spMkLst>
-          </pc:spChg>
-          <pc:spChg chg="add mod ord">
-            <ac:chgData name="Sam Khalil" userId="82cd1ec2-6208-465b-9d4d-40ce8f0cbf96" providerId="ADAL" clId="{85B83225-0F8B-4540-96C4-3916D224CEC7}" dt="2025-08-13T21:04:24.613" v="735" actId="404"/>
-            <ac:spMkLst>
-              <pc:docMk/>
-              <pc:sldMasterMk cId="3143898779" sldId="2147483768"/>
-              <pc:sldLayoutMk cId="1278989944" sldId="2147483769"/>
-              <ac:spMk id="24" creationId="{16340594-85F5-7351-94DD-402DEF96C31A}"/>
-            </ac:spMkLst>
-          </pc:spChg>
-          <pc:picChg chg="add del mod modVis">
-            <ac:chgData name="Sam Khalil" userId="82cd1ec2-6208-465b-9d4d-40ce8f0cbf96" providerId="ADAL" clId="{85B83225-0F8B-4540-96C4-3916D224CEC7}" dt="2025-08-13T21:11:01.265" v="948" actId="478"/>
-            <ac:picMkLst>
-              <pc:docMk/>
-              <pc:sldMasterMk cId="3143898779" sldId="2147483768"/>
-              <pc:sldLayoutMk cId="1278989944" sldId="2147483769"/>
-              <ac:picMk id="3" creationId="{5444FF1F-2817-69BD-4197-7A23DDB23341}"/>
-            </ac:picMkLst>
-          </pc:picChg>
-          <pc:picChg chg="mod modVis">
-            <ac:chgData name="Sam Khalil" userId="82cd1ec2-6208-465b-9d4d-40ce8f0cbf96" providerId="ADAL" clId="{85B83225-0F8B-4540-96C4-3916D224CEC7}" dt="2025-08-13T22:17:39.405" v="965" actId="14429"/>
+          <pc:picChg chg="mod">
+            <ac:chgData name="Sam Khalil" userId="82cd1ec2-6208-465b-9d4d-40ce8f0cbf96" providerId="ADAL" clId="{87A27B4C-FB13-9545-B06C-83D288B68DDE}" dt="2025-08-15T06:53:03.317" v="205" actId="1076"/>
             <ac:picMkLst>
               <pc:docMk/>
               <pc:sldMasterMk cId="3143898779" sldId="2147483768"/>
@@ -350,6 +905,118 @@
               <ac:picMk id="7" creationId="{6946BB1A-98D8-E187-4BB0-0EE691956D32}"/>
             </ac:picMkLst>
           </pc:picChg>
+        </pc:sldLayoutChg>
+        <pc:sldLayoutChg chg="delSp mod">
+          <pc:chgData name="Sam Khalil" userId="82cd1ec2-6208-465b-9d4d-40ce8f0cbf96" providerId="ADAL" clId="{87A27B4C-FB13-9545-B06C-83D288B68DDE}" dt="2025-08-15T08:25:16.413" v="283" actId="478"/>
+          <pc:sldLayoutMkLst>
+            <pc:docMk/>
+            <pc:sldMasterMk cId="3143898779" sldId="2147483768"/>
+            <pc:sldLayoutMk cId="1000131499" sldId="2147483771"/>
+          </pc:sldLayoutMkLst>
+          <pc:spChg chg="del">
+            <ac:chgData name="Sam Khalil" userId="82cd1ec2-6208-465b-9d4d-40ce8f0cbf96" providerId="ADAL" clId="{87A27B4C-FB13-9545-B06C-83D288B68DDE}" dt="2025-08-15T08:25:16.413" v="283" actId="478"/>
+            <ac:spMkLst>
+              <pc:docMk/>
+              <pc:sldMasterMk cId="3143898779" sldId="2147483768"/>
+              <pc:sldLayoutMk cId="1000131499" sldId="2147483771"/>
+              <ac:spMk id="2" creationId="{EAADA53C-B47C-D525-3561-B981E239AF4B}"/>
+            </ac:spMkLst>
+          </pc:spChg>
+        </pc:sldLayoutChg>
+      </pc:sldMasterChg>
+      <pc:sldMasterChg chg="new del mod addSldLayout delSldLayout">
+        <pc:chgData name="Sam Khalil" userId="82cd1ec2-6208-465b-9d4d-40ce8f0cbf96" providerId="ADAL" clId="{87A27B4C-FB13-9545-B06C-83D288B68DDE}" dt="2025-08-15T08:25:07.606" v="282" actId="6938"/>
+        <pc:sldMasterMkLst>
+          <pc:docMk/>
+          <pc:sldMasterMk cId="4069819825" sldId="2147483771"/>
+        </pc:sldMasterMkLst>
+        <pc:sldLayoutChg chg="new del replId">
+          <pc:chgData name="Sam Khalil" userId="82cd1ec2-6208-465b-9d4d-40ce8f0cbf96" providerId="ADAL" clId="{87A27B4C-FB13-9545-B06C-83D288B68DDE}" dt="2025-08-15T08:25:07.606" v="282" actId="6938"/>
+          <pc:sldLayoutMkLst>
+            <pc:docMk/>
+            <pc:sldMasterMk cId="4069819825" sldId="2147483771"/>
+            <pc:sldLayoutMk cId="3316338171" sldId="2147483772"/>
+          </pc:sldLayoutMkLst>
+        </pc:sldLayoutChg>
+        <pc:sldLayoutChg chg="new del replId">
+          <pc:chgData name="Sam Khalil" userId="82cd1ec2-6208-465b-9d4d-40ce8f0cbf96" providerId="ADAL" clId="{87A27B4C-FB13-9545-B06C-83D288B68DDE}" dt="2025-08-15T08:25:07.606" v="282" actId="6938"/>
+          <pc:sldLayoutMkLst>
+            <pc:docMk/>
+            <pc:sldMasterMk cId="4069819825" sldId="2147483771"/>
+            <pc:sldLayoutMk cId="765643686" sldId="2147483773"/>
+          </pc:sldLayoutMkLst>
+        </pc:sldLayoutChg>
+        <pc:sldLayoutChg chg="new del replId">
+          <pc:chgData name="Sam Khalil" userId="82cd1ec2-6208-465b-9d4d-40ce8f0cbf96" providerId="ADAL" clId="{87A27B4C-FB13-9545-B06C-83D288B68DDE}" dt="2025-08-15T08:25:07.606" v="282" actId="6938"/>
+          <pc:sldLayoutMkLst>
+            <pc:docMk/>
+            <pc:sldMasterMk cId="4069819825" sldId="2147483771"/>
+            <pc:sldLayoutMk cId="1229239337" sldId="2147483774"/>
+          </pc:sldLayoutMkLst>
+        </pc:sldLayoutChg>
+        <pc:sldLayoutChg chg="new del replId">
+          <pc:chgData name="Sam Khalil" userId="82cd1ec2-6208-465b-9d4d-40ce8f0cbf96" providerId="ADAL" clId="{87A27B4C-FB13-9545-B06C-83D288B68DDE}" dt="2025-08-15T08:25:07.606" v="282" actId="6938"/>
+          <pc:sldLayoutMkLst>
+            <pc:docMk/>
+            <pc:sldMasterMk cId="4069819825" sldId="2147483771"/>
+            <pc:sldLayoutMk cId="2926012672" sldId="2147483775"/>
+          </pc:sldLayoutMkLst>
+        </pc:sldLayoutChg>
+        <pc:sldLayoutChg chg="new del replId">
+          <pc:chgData name="Sam Khalil" userId="82cd1ec2-6208-465b-9d4d-40ce8f0cbf96" providerId="ADAL" clId="{87A27B4C-FB13-9545-B06C-83D288B68DDE}" dt="2025-08-15T08:25:07.606" v="282" actId="6938"/>
+          <pc:sldLayoutMkLst>
+            <pc:docMk/>
+            <pc:sldMasterMk cId="4069819825" sldId="2147483771"/>
+            <pc:sldLayoutMk cId="1439163829" sldId="2147483776"/>
+          </pc:sldLayoutMkLst>
+        </pc:sldLayoutChg>
+        <pc:sldLayoutChg chg="new del replId">
+          <pc:chgData name="Sam Khalil" userId="82cd1ec2-6208-465b-9d4d-40ce8f0cbf96" providerId="ADAL" clId="{87A27B4C-FB13-9545-B06C-83D288B68DDE}" dt="2025-08-15T08:25:07.606" v="282" actId="6938"/>
+          <pc:sldLayoutMkLst>
+            <pc:docMk/>
+            <pc:sldMasterMk cId="4069819825" sldId="2147483771"/>
+            <pc:sldLayoutMk cId="2301493419" sldId="2147483777"/>
+          </pc:sldLayoutMkLst>
+        </pc:sldLayoutChg>
+        <pc:sldLayoutChg chg="new del replId">
+          <pc:chgData name="Sam Khalil" userId="82cd1ec2-6208-465b-9d4d-40ce8f0cbf96" providerId="ADAL" clId="{87A27B4C-FB13-9545-B06C-83D288B68DDE}" dt="2025-08-15T08:25:07.606" v="282" actId="6938"/>
+          <pc:sldLayoutMkLst>
+            <pc:docMk/>
+            <pc:sldMasterMk cId="4069819825" sldId="2147483771"/>
+            <pc:sldLayoutMk cId="3431512907" sldId="2147483778"/>
+          </pc:sldLayoutMkLst>
+        </pc:sldLayoutChg>
+        <pc:sldLayoutChg chg="new del replId">
+          <pc:chgData name="Sam Khalil" userId="82cd1ec2-6208-465b-9d4d-40ce8f0cbf96" providerId="ADAL" clId="{87A27B4C-FB13-9545-B06C-83D288B68DDE}" dt="2025-08-15T08:25:07.606" v="282" actId="6938"/>
+          <pc:sldLayoutMkLst>
+            <pc:docMk/>
+            <pc:sldMasterMk cId="4069819825" sldId="2147483771"/>
+            <pc:sldLayoutMk cId="98181419" sldId="2147483779"/>
+          </pc:sldLayoutMkLst>
+        </pc:sldLayoutChg>
+        <pc:sldLayoutChg chg="new del replId">
+          <pc:chgData name="Sam Khalil" userId="82cd1ec2-6208-465b-9d4d-40ce8f0cbf96" providerId="ADAL" clId="{87A27B4C-FB13-9545-B06C-83D288B68DDE}" dt="2025-08-15T08:25:07.606" v="282" actId="6938"/>
+          <pc:sldLayoutMkLst>
+            <pc:docMk/>
+            <pc:sldMasterMk cId="4069819825" sldId="2147483771"/>
+            <pc:sldLayoutMk cId="4070096628" sldId="2147483780"/>
+          </pc:sldLayoutMkLst>
+        </pc:sldLayoutChg>
+        <pc:sldLayoutChg chg="new del replId">
+          <pc:chgData name="Sam Khalil" userId="82cd1ec2-6208-465b-9d4d-40ce8f0cbf96" providerId="ADAL" clId="{87A27B4C-FB13-9545-B06C-83D288B68DDE}" dt="2025-08-15T08:25:07.606" v="282" actId="6938"/>
+          <pc:sldLayoutMkLst>
+            <pc:docMk/>
+            <pc:sldMasterMk cId="4069819825" sldId="2147483771"/>
+            <pc:sldLayoutMk cId="675702848" sldId="2147483781"/>
+          </pc:sldLayoutMkLst>
+        </pc:sldLayoutChg>
+        <pc:sldLayoutChg chg="new del replId">
+          <pc:chgData name="Sam Khalil" userId="82cd1ec2-6208-465b-9d4d-40ce8f0cbf96" providerId="ADAL" clId="{87A27B4C-FB13-9545-B06C-83D288B68DDE}" dt="2025-08-15T08:25:07.606" v="282" actId="6938"/>
+          <pc:sldLayoutMkLst>
+            <pc:docMk/>
+            <pc:sldMasterMk cId="4069819825" sldId="2147483771"/>
+            <pc:sldLayoutMk cId="1509056063" sldId="2147483782"/>
+          </pc:sldLayoutMkLst>
         </pc:sldLayoutChg>
       </pc:sldMasterChg>
     </pc:docChg>
@@ -451,7 +1118,7 @@
           <a:p>
             <a:fld id="{85DFCB00-05F5-7646-BC5F-7ACFDEEC4F5E}" type="datetimeFigureOut">
               <a:rPr lang="en-US" smtClean="0"/>
-              <a:t>8/14/25</a:t>
+              <a:t>8/15/25</a:t>
             </a:fld>
             <a:endParaRPr lang="en-US"/>
           </a:p>
@@ -722,29 +1389,25 @@
               </a:spcBef>
               <a:buFontTx/>
               <a:buNone/>
-              <a:defRPr lang="en-US" sz="500" dirty="0"/>
+              <a:defRPr lang="en-US" sz="500" b="1" dirty="0">
+                <a:solidFill>
+                  <a:srgbClr val="002060"/>
+                </a:solidFill>
+                <a:latin typeface="Helvetica" pitchFamily="2" charset="0"/>
+              </a:defRPr>
             </a:lvl1pPr>
           </a:lstStyle>
           <a:p>
             <a:r>
-              <a:rPr lang="en-US" b="1" dirty="0">
+              <a:rPr lang="en-US" dirty="0">
                 <a:solidFill>
                   <a:srgbClr val="101E65"/>
                 </a:solidFill>
                 <a:effectLst/>
                 <a:latin typeface="Helvetica" pitchFamily="2" charset="0"/>
               </a:rPr>
-              <a:t>References </a:t>
+              <a:t>REFERENCES</a:t>
             </a:r>
-          </a:p>
-          <a:p>
-            <a:endParaRPr lang="en-US" dirty="0">
-              <a:solidFill>
-                <a:srgbClr val="101E65"/>
-              </a:solidFill>
-              <a:effectLst/>
-              <a:latin typeface="Helvetica" pitchFamily="2" charset="0"/>
-            </a:endParaRPr>
           </a:p>
           <a:p>
             <a:pPr lvl="0"/>
@@ -793,7 +1456,12 @@
               <a:buFont typeface="+mj-lt"/>
               <a:buAutoNum type="arabicPeriod"/>
               <a:tabLst/>
-              <a:defRPr lang="en-US" sz="460" b="1" dirty="0"/>
+              <a:defRPr lang="en-US" sz="460" b="1" dirty="0">
+                <a:solidFill>
+                  <a:srgbClr val="002060"/>
+                </a:solidFill>
+                <a:latin typeface="Helvetica" pitchFamily="2" charset="0"/>
+              </a:defRPr>
             </a:lvl1pPr>
             <a:lvl2pPr>
               <a:defRPr sz="1100">
@@ -904,142 +1572,6 @@
                 <a:latin typeface="Helvetica" pitchFamily="2" charset="0"/>
               </a:rPr>
               <a:t> Online survey Sweden 2017. 352 respondents. People with diabetes Type 1 and Type 2, over 18 years old who tested at least 4-7 times a day. Participants received free meter and test strips </a:t>
-            </a:r>
-          </a:p>
-        </p:txBody>
-      </p:sp>
-      <p:sp>
-        <p:nvSpPr>
-          <p:cNvPr id="5" name="Ascensia Service Phone number">
-            <a:extLst>
-              <a:ext uri="{FF2B5EF4-FFF2-40B4-BE49-F238E27FC236}">
-                <a16:creationId xmlns:a16="http://schemas.microsoft.com/office/drawing/2014/main" id="{76F7200D-FEA1-CF69-A14D-E72026F4494E}"/>
-              </a:ext>
-            </a:extLst>
-          </p:cNvPr>
-          <p:cNvSpPr>
-            <a:spLocks noGrp="1"/>
-          </p:cNvSpPr>
-          <p:nvPr>
-            <p:ph type="body" sz="quarter" idx="12" hasCustomPrompt="1"/>
-          </p:nvPr>
-        </p:nvSpPr>
-        <p:spPr>
-          <a:xfrm>
-            <a:off x="3355115" y="3271091"/>
-            <a:ext cx="2420963" cy="614363"/>
-          </a:xfrm>
-          <a:prstGeom prst="rect">
-            <a:avLst/>
-          </a:prstGeom>
-        </p:spPr>
-        <p:txBody>
-          <a:bodyPr/>
-          <a:lstStyle>
-            <a:lvl1pPr marL="0" marR="0" indent="0" algn="l" defTabSz="861913" rtl="0" eaLnBrk="1" fontAlgn="auto" latinLnBrk="0" hangingPunct="1">
-              <a:lnSpc>
-                <a:spcPct val="100000"/>
-              </a:lnSpc>
-              <a:spcBef>
-                <a:spcPts val="0"/>
-              </a:spcBef>
-              <a:spcAft>
-                <a:spcPts val="0"/>
-              </a:spcAft>
-              <a:buClrTx/>
-              <a:buSzTx/>
-              <a:buFont typeface="Arial" panose="020B0604020202020204" pitchFamily="34" charset="0"/>
-              <a:buNone/>
-              <a:tabLst/>
-              <a:defRPr lang="en-US" sz="1000" dirty="0" smtClean="0"/>
-            </a:lvl1pPr>
-            <a:lvl2pPr>
-              <a:defRPr sz="1100">
-                <a:latin typeface="Helvetica" pitchFamily="2" charset="0"/>
-              </a:defRPr>
-            </a:lvl2pPr>
-            <a:lvl3pPr>
-              <a:defRPr sz="1050">
-                <a:latin typeface="Helvetica" pitchFamily="2" charset="0"/>
-              </a:defRPr>
-            </a:lvl3pPr>
-            <a:lvl4pPr>
-              <a:defRPr sz="1000">
-                <a:latin typeface="Helvetica" pitchFamily="2" charset="0"/>
-              </a:defRPr>
-            </a:lvl4pPr>
-            <a:lvl5pPr>
-              <a:defRPr sz="1000">
-                <a:latin typeface="Helvetica" pitchFamily="2" charset="0"/>
-              </a:defRPr>
-            </a:lvl5pPr>
-          </a:lstStyle>
-          <a:p>
-            <a:r>
-              <a:rPr lang="en-US" b="1" dirty="0">
-                <a:solidFill>
-                  <a:srgbClr val="101E65"/>
-                </a:solidFill>
-                <a:effectLst/>
-                <a:latin typeface="Helvetica" pitchFamily="2" charset="0"/>
-              </a:rPr>
-              <a:t>Ascensia Diabetes Service:</a:t>
-            </a:r>
-          </a:p>
-          <a:p>
-            <a:r>
-              <a:rPr lang="en-US" b="1" dirty="0">
-                <a:solidFill>
-                  <a:srgbClr val="101E65"/>
-                </a:solidFill>
-                <a:effectLst/>
-                <a:latin typeface="Helvetica" pitchFamily="2" charset="0"/>
-              </a:rPr>
-              <a:t>0000 / 00 00 880 (free of charge) </a:t>
-            </a:r>
-          </a:p>
-          <a:p>
-            <a:r>
-              <a:rPr lang="en-US" b="1" dirty="0" err="1">
-                <a:solidFill>
-                  <a:srgbClr val="101E65"/>
-                </a:solidFill>
-                <a:effectLst/>
-                <a:latin typeface="Helvetica" pitchFamily="2" charset="0"/>
-              </a:rPr>
-              <a:t>info@ascensia.xx</a:t>
-            </a:r>
-            <a:r>
-              <a:rPr lang="en-US" b="1" dirty="0">
-                <a:solidFill>
-                  <a:srgbClr val="101E65"/>
-                </a:solidFill>
-                <a:effectLst/>
-                <a:latin typeface="Helvetica" pitchFamily="2" charset="0"/>
-              </a:rPr>
-              <a:t> </a:t>
-            </a:r>
-          </a:p>
-          <a:p>
-            <a:r>
-              <a:rPr lang="en-US" b="1" dirty="0" err="1">
-                <a:solidFill>
-                  <a:srgbClr val="101E65"/>
-                </a:solidFill>
-                <a:effectLst/>
-                <a:latin typeface="Helvetica" pitchFamily="2" charset="0"/>
-              </a:rPr>
-              <a:t>www.diabetes.ascensia.xx</a:t>
-            </a:r>
-            <a:r>
-              <a:rPr lang="en-US" b="1" dirty="0">
-                <a:solidFill>
-                  <a:srgbClr val="101E65"/>
-                </a:solidFill>
-                <a:effectLst/>
-                <a:latin typeface="Helvetica" pitchFamily="2" charset="0"/>
-              </a:rPr>
-              <a:t> </a:t>
             </a:r>
           </a:p>
         </p:txBody>
@@ -1086,7 +1618,11 @@
               <a:buNone/>
               <a:tabLst/>
               <a:defRPr lang="en-US" sz="400" smtClean="0">
+                <a:solidFill>
+                  <a:srgbClr val="002060"/>
+                </a:solidFill>
                 <a:effectLst/>
+                <a:latin typeface="Helvetica" pitchFamily="2" charset="0"/>
               </a:defRPr>
             </a:lvl1pPr>
             <a:lvl2pPr>
@@ -1241,7 +1777,7 @@
               <a:buFont typeface="Arial" panose="020B0604020202020204" pitchFamily="34" charset="0"/>
               <a:buNone/>
               <a:tabLst/>
-              <a:defRPr lang="en-US" sz="1400" noProof="0" dirty="0" smtClean="0">
+              <a:defRPr lang="en-US" sz="1400" b="1" noProof="0" dirty="0" smtClean="0">
                 <a:solidFill>
                   <a:schemeClr val="bg1"/>
                 </a:solidFill>
@@ -1252,7 +1788,7 @@
           <a:p>
             <a:r>
               <a:rPr lang="en-US" dirty="0"/>
-              <a:t>HTML content to be inserted here. Can be Text, images, infographics or other.</a:t>
+              <a:t>HTML content to be inserted here.</a:t>
             </a:r>
           </a:p>
         </p:txBody>
@@ -1287,7 +1823,7 @@
           <a:lstStyle>
             <a:lvl1pPr marL="0" indent="0">
               <a:buNone/>
-              <a:defRPr sz="1400">
+              <a:defRPr sz="1400" b="1">
                 <a:solidFill>
                   <a:schemeClr val="bg1"/>
                 </a:solidFill>
@@ -1298,7 +1834,7 @@
           <a:p>
             <a:r>
               <a:rPr lang="en-US" dirty="0"/>
-              <a:t>HTML content to be inserted here. Can be Text, images, infographics or other.</a:t>
+              <a:t>HTML content to be inserted here. </a:t>
             </a:r>
           </a:p>
         </p:txBody>
@@ -1321,7 +1857,7 @@
         </p:nvSpPr>
         <p:spPr>
           <a:xfrm>
-            <a:off x="6317238" y="4894241"/>
+            <a:off x="6317238" y="4980510"/>
             <a:ext cx="2820412" cy="581025"/>
           </a:xfrm>
           <a:prstGeom prst="rect">
@@ -1338,6 +1874,7 @@
                   <a:schemeClr val="bg1"/>
                 </a:solidFill>
                 <a:effectLst/>
+                <a:latin typeface="Helvetica" pitchFamily="2" charset="0"/>
               </a:defRPr>
             </a:lvl1pPr>
             <a:lvl2pPr>
@@ -1401,7 +1938,7 @@
         <p:spPr>
           <a:xfrm>
             <a:off x="6310781" y="4224516"/>
-            <a:ext cx="2106904" cy="373063"/>
+            <a:ext cx="2106904" cy="581025"/>
           </a:xfrm>
           <a:prstGeom prst="rect">
             <a:avLst/>
@@ -1419,7 +1956,7 @@
               </a:spcBef>
               <a:buFont typeface="+mj-lt"/>
               <a:buNone/>
-              <a:defRPr sz="1800">
+              <a:defRPr sz="1800" b="1">
                 <a:solidFill>
                   <a:schemeClr val="bg1"/>
                 </a:solidFill>
@@ -1467,6 +2004,53 @@
             <a:r>
               <a:rPr lang="en-US" dirty="0"/>
               <a:t>Self-monitoring</a:t>
+            </a:r>
+          </a:p>
+        </p:txBody>
+      </p:sp>
+      <p:sp>
+        <p:nvSpPr>
+          <p:cNvPr id="6" name="Ascensia Service Phone number">
+            <a:extLst>
+              <a:ext uri="{FF2B5EF4-FFF2-40B4-BE49-F238E27FC236}">
+                <a16:creationId xmlns:a16="http://schemas.microsoft.com/office/drawing/2014/main" id="{4159A364-144D-E2C8-29D6-EE565EC808D9}"/>
+              </a:ext>
+            </a:extLst>
+          </p:cNvPr>
+          <p:cNvSpPr>
+            <a:spLocks noGrp="1"/>
+          </p:cNvSpPr>
+          <p:nvPr>
+            <p:ph type="body" sz="quarter" idx="23" hasCustomPrompt="1"/>
+          </p:nvPr>
+        </p:nvSpPr>
+        <p:spPr>
+          <a:xfrm>
+            <a:off x="3288438" y="3239816"/>
+            <a:ext cx="2492375" cy="646112"/>
+          </a:xfrm>
+          <a:prstGeom prst="rect">
+            <a:avLst/>
+          </a:prstGeom>
+        </p:spPr>
+        <p:txBody>
+          <a:bodyPr/>
+          <a:lstStyle>
+            <a:lvl1pPr marL="0" indent="0">
+              <a:buNone/>
+              <a:defRPr sz="1100" b="1">
+                <a:solidFill>
+                  <a:srgbClr val="002060"/>
+                </a:solidFill>
+                <a:latin typeface="Helvetica" pitchFamily="2" charset="0"/>
+              </a:defRPr>
+            </a:lvl1pPr>
+          </a:lstStyle>
+          <a:p>
+            <a:pPr lvl="0"/>
+            <a:r>
+              <a:rPr lang="en-US" dirty="0"/>
+              <a:t>CONTACT INFO</a:t>
             </a:r>
           </a:p>
         </p:txBody>
@@ -2498,6 +3082,15 @@
 </file>
 
 <file path=customXml/item1.xml><?xml version="1.0" encoding="utf-8"?>
+<?mso-contentType ?>
+<FormTemplates xmlns="http://schemas.microsoft.com/sharepoint/v3/contenttype/forms">
+  <Display>DocumentLibraryForm</Display>
+  <Edit>DocumentLibraryForm</Edit>
+  <New>DocumentLibraryForm</New>
+</FormTemplates>
+</file>
+
+<file path=customXml/item2.xml><?xml version="1.0" encoding="utf-8"?>
 <ct:contentTypeSchema xmlns:ct="http://schemas.microsoft.com/office/2006/metadata/contentType" xmlns:ma="http://schemas.microsoft.com/office/2006/metadata/properties/metaAttributes" ct:_="" ma:_="" ma:contentTypeName="Document" ma:contentTypeID="0x0101009D55CCFAD34A484FAC43376D580F7497" ma:contentTypeVersion="13" ma:contentTypeDescription="Create a new document." ma:contentTypeScope="" ma:versionID="20fcfebd8cb07aba400aa359cb6a137d">
   <xsd:schema xmlns:xsd="http://www.w3.org/2001/XMLSchema" xmlns:xs="http://www.w3.org/2001/XMLSchema" xmlns:p="http://schemas.microsoft.com/office/2006/metadata/properties" xmlns:ns2="bdfda862-7558-4f4e-99f8-648970d7935e" xmlns:ns3="2bdccfd7-ed75-47c4-ae3e-45ba8291135b" targetNamespace="http://schemas.microsoft.com/office/2006/metadata/properties" ma:root="true" ma:fieldsID="e7232410060904e04ccc6d86ba125b69" ns2:_="" ns3:_="">
     <xsd:import namespace="bdfda862-7558-4f4e-99f8-648970d7935e"/>
@@ -2704,15 +3297,6 @@
 </ct:contentTypeSchema>
 </file>
 
-<file path=customXml/item2.xml><?xml version="1.0" encoding="utf-8"?>
-<?mso-contentType ?>
-<FormTemplates xmlns="http://schemas.microsoft.com/sharepoint/v3/contenttype/forms">
-  <Display>DocumentLibraryForm</Display>
-  <Edit>DocumentLibraryForm</Edit>
-  <New>DocumentLibraryForm</New>
-</FormTemplates>
-</file>
-
 <file path=customXml/item3.xml><?xml version="1.0" encoding="utf-8"?>
 <p:properties xmlns:p="http://schemas.microsoft.com/office/2006/metadata/properties" xmlns:xsi="http://www.w3.org/2001/XMLSchema-instance" xmlns:pc="http://schemas.microsoft.com/office/infopath/2007/PartnerControls">
   <documentManagement>
@@ -2725,6 +3309,14 @@
 </file>
 
 <file path=customXml/itemProps1.xml><?xml version="1.0" encoding="utf-8"?>
+<ds:datastoreItem xmlns:ds="http://schemas.openxmlformats.org/officeDocument/2006/customXml" ds:itemID="{51BB2657-A3D8-435D-ABCC-EAD347EFA0A4}">
+  <ds:schemaRefs>
+    <ds:schemaRef ds:uri="http://schemas.microsoft.com/sharepoint/v3/contenttype/forms"/>
+  </ds:schemaRefs>
+</ds:datastoreItem>
+</file>
+
+<file path=customXml/itemProps2.xml><?xml version="1.0" encoding="utf-8"?>
 <ds:datastoreItem xmlns:ds="http://schemas.openxmlformats.org/officeDocument/2006/customXml" ds:itemID="{65458A40-C344-4C63-946C-148A053E988A}">
   <ds:schemaRefs>
     <ds:schemaRef ds:uri="http://schemas.microsoft.com/office/2006/metadata/contentType"/>
@@ -2743,27 +3335,19 @@
 </ds:datastoreItem>
 </file>
 
-<file path=customXml/itemProps2.xml><?xml version="1.0" encoding="utf-8"?>
-<ds:datastoreItem xmlns:ds="http://schemas.openxmlformats.org/officeDocument/2006/customXml" ds:itemID="{51BB2657-A3D8-435D-ABCC-EAD347EFA0A4}">
-  <ds:schemaRefs>
-    <ds:schemaRef ds:uri="http://schemas.microsoft.com/sharepoint/v3/contenttype/forms"/>
-  </ds:schemaRefs>
-</ds:datastoreItem>
-</file>
-
 <file path=customXml/itemProps3.xml><?xml version="1.0" encoding="utf-8"?>
 <ds:datastoreItem xmlns:ds="http://schemas.openxmlformats.org/officeDocument/2006/customXml" ds:itemID="{1722C4D8-7046-43E3-B8BC-A45BA1E55AF2}">
   <ds:schemaRefs>
+    <ds:schemaRef ds:uri="http://schemas.microsoft.com/office/2006/documentManagement/types"/>
     <ds:schemaRef ds:uri="bdfda862-7558-4f4e-99f8-648970d7935e"/>
+    <ds:schemaRef ds:uri="http://www.w3.org/XML/1998/namespace"/>
     <ds:schemaRef ds:uri="http://purl.org/dc/elements/1.1/"/>
+    <ds:schemaRef ds:uri="http://purl.org/dc/terms/"/>
     <ds:schemaRef ds:uri="http://schemas.microsoft.com/office/2006/metadata/properties"/>
+    <ds:schemaRef ds:uri="http://schemas.openxmlformats.org/package/2006/metadata/core-properties"/>
+    <ds:schemaRef ds:uri="http://schemas.microsoft.com/office/infopath/2007/PartnerControls"/>
     <ds:schemaRef ds:uri="2bdccfd7-ed75-47c4-ae3e-45ba8291135b"/>
     <ds:schemaRef ds:uri="http://purl.org/dc/dcmitype/"/>
-    <ds:schemaRef ds:uri="http://schemas.microsoft.com/office/infopath/2007/PartnerControls"/>
-    <ds:schemaRef ds:uri="http://schemas.microsoft.com/office/2006/documentManagement/types"/>
-    <ds:schemaRef ds:uri="http://www.w3.org/XML/1998/namespace"/>
-    <ds:schemaRef ds:uri="http://purl.org/dc/terms/"/>
-    <ds:schemaRef ds:uri="http://schemas.openxmlformats.org/package/2006/metadata/core-properties"/>
   </ds:schemaRefs>
 </ds:datastoreItem>
 </file>
</xml_diff>